<commit_message>
feat(business): settle 参课蓝金样 + green-line 2-combo proof
Promote disease-health-shenke-blue-v1 as the 7th settled template on the
business shelf (catalog, guides, package, docs, style pack). Refresh the
WorkBuddy delivery package and record the green product PPT smoke path for
two combination rows so local dirty lessons/todo no longer block pull sync.
</commit_message>
<xml_diff>
--- a/production-library/templates/settled/product-courseware-green-v1/金银花露_商品培训课件_复刻验证.pptx
+++ b/production-library/templates/settled/product-courseware-green-v1/金银花露_商品培训课件_复刻验证.pptx
@@ -2,17 +2,17 @@
 <file path=ppt/presentation.xml><?xml version="1.0" encoding="utf-8"?>
 <p:presentation xmlns:p="http://schemas.openxmlformats.org/presentationml/2006/main">
   <p:sldMasterIdLst>
-    <p:sldMasterId xmlns:r="http://schemas.openxmlformats.org/officeDocument/2006/relationships" id="2147483648" r:id="Re1e46ec39d7244f8"/>
+    <p:sldMasterId xmlns:r="http://schemas.openxmlformats.org/officeDocument/2006/relationships" id="2147483648" r:id="R6c948c2a960a48f8"/>
   </p:sldMasterIdLst>
   <p:notesMasterIdLst>
-    <p:notesMasterId xmlns:r="http://schemas.openxmlformats.org/officeDocument/2006/relationships" r:id="R6fea4b73fd074792"/>
+    <p:notesMasterId xmlns:r="http://schemas.openxmlformats.org/officeDocument/2006/relationships" r:id="R4990dc86d54b49a7"/>
   </p:notesMasterIdLst>
   <p:sldIdLst>
-    <p:sldId xmlns:r="http://schemas.openxmlformats.org/officeDocument/2006/relationships" id="256" r:id="Re3159d3713ed4fb7"/>
-    <p:sldId xmlns:r="http://schemas.openxmlformats.org/officeDocument/2006/relationships" id="257" r:id="Rb28db05e376d4d05"/>
-    <p:sldId xmlns:r="http://schemas.openxmlformats.org/officeDocument/2006/relationships" id="258" r:id="R40663094ed3c455d"/>
-    <p:sldId xmlns:r="http://schemas.openxmlformats.org/officeDocument/2006/relationships" id="259" r:id="R8e885db1df9d4cc2"/>
-    <p:sldId xmlns:r="http://schemas.openxmlformats.org/officeDocument/2006/relationships" id="260" r:id="R5ce9db735e0e447a"/>
+    <p:sldId xmlns:r="http://schemas.openxmlformats.org/officeDocument/2006/relationships" id="256" r:id="R9c0992d9e26b416c"/>
+    <p:sldId xmlns:r="http://schemas.openxmlformats.org/officeDocument/2006/relationships" id="257" r:id="R795af62e449441fa"/>
+    <p:sldId xmlns:r="http://schemas.openxmlformats.org/officeDocument/2006/relationships" id="258" r:id="R4b6cadb09d1f4b45"/>
+    <p:sldId xmlns:r="http://schemas.openxmlformats.org/officeDocument/2006/relationships" id="259" r:id="R395d01921096433a"/>
+    <p:sldId xmlns:r="http://schemas.openxmlformats.org/officeDocument/2006/relationships" id="260" r:id="Rdc727c848b174f29"/>
   </p:sldIdLst>
   <p:sldSz cx="12192000" cy="6858000"/>
   <p:notesSz cx="6858000" cy="9144000"/>
@@ -869,7 +869,7 @@
   </p:cSld>
   <p:clrMap bg1="lt1" tx1="dk1" bg2="lt2" tx2="dk2" accent1="accent1" accent2="accent2" accent3="accent3" accent4="accent4" accent5="accent5" accent6="accent6" hlink="hlink" folHlink="folHlink"/>
   <p:sldLayoutIdLst>
-    <p:sldLayoutId xmlns:r="http://schemas.openxmlformats.org/officeDocument/2006/relationships" id="2147483649" r:id="Rd0b8223459014259"/>
+    <p:sldLayoutId xmlns:r="http://schemas.openxmlformats.org/officeDocument/2006/relationships" id="2147483649" r:id="Rd36a7ec6f5e94d80"/>
   </p:sldLayoutIdLst>
   <p:txStyles>
     <p:titleStyle>
@@ -1420,7 +1420,7 @@
           <p:cNvPr id="27" name="cover-color-field">
             <a:extLst xmlns:a="http://schemas.openxmlformats.org/drawingml/2006/main">
               <a:ext uri="{FF2B5EF4-FFF2-40B4-BE49-F238E27FC236}">
-                <a16:creationId xmlns:a16="http://schemas.microsoft.com/office/drawing/2014/main" id="{831FD66E-4265-48E8-9F42-A56D1B5D2878}"/>
+                <a16:creationId xmlns:a16="http://schemas.microsoft.com/office/drawing/2014/main" id="{B9597C85-5559-46E8-A511-19721177C874}"/>
               </a:ext>
             </a:extLst>
           </p:cNvPr>
@@ -1451,7 +1451,7 @@
           <p:cNvPr id="2" name="cover-blue-field">
             <a:extLst xmlns:a="http://schemas.openxmlformats.org/drawingml/2006/main">
               <a:ext uri="{FF2B5EF4-FFF2-40B4-BE49-F238E27FC236}">
-                <a16:creationId xmlns:a16="http://schemas.microsoft.com/office/drawing/2014/main" id="{A1135855-76B9-465A-A60E-D4352ABD44CE}"/>
+                <a16:creationId xmlns:a16="http://schemas.microsoft.com/office/drawing/2014/main" id="{76CE8515-6B88-4188-ACBC-49033EDB072A}"/>
               </a:ext>
             </a:extLst>
           </p:cNvPr>
@@ -1482,7 +1482,7 @@
           <p:cNvPr id="3" name="cover-green-overlay">
             <a:extLst xmlns:a="http://schemas.openxmlformats.org/drawingml/2006/main">
               <a:ext uri="{FF2B5EF4-FFF2-40B4-BE49-F238E27FC236}">
-                <a16:creationId xmlns:a16="http://schemas.microsoft.com/office/drawing/2014/main" id="{F6C828B6-2F8A-486A-A688-A27FD3F0F2FE}"/>
+                <a16:creationId xmlns:a16="http://schemas.microsoft.com/office/drawing/2014/main" id="{3F3FED0D-ECF2-4618-88FF-AB5A31E0BD5B}"/>
               </a:ext>
             </a:extLst>
           </p:cNvPr>
@@ -1513,7 +1513,7 @@
           <p:cNvPr id="4" name="cover-building-band-1">
             <a:extLst xmlns:a="http://schemas.openxmlformats.org/drawingml/2006/main">
               <a:ext uri="{FF2B5EF4-FFF2-40B4-BE49-F238E27FC236}">
-                <a16:creationId xmlns:a16="http://schemas.microsoft.com/office/drawing/2014/main" id="{FD1B470C-BD06-4AEB-AEB2-0BA4DE7BD949}"/>
+                <a16:creationId xmlns:a16="http://schemas.microsoft.com/office/drawing/2014/main" id="{F9BF3FF7-21C6-4DEE-B642-2FEF4FB4A389}"/>
               </a:ext>
             </a:extLst>
           </p:cNvPr>
@@ -1544,7 +1544,7 @@
           <p:cNvPr id="5" name="cover-building-band-2">
             <a:extLst xmlns:a="http://schemas.openxmlformats.org/drawingml/2006/main">
               <a:ext uri="{FF2B5EF4-FFF2-40B4-BE49-F238E27FC236}">
-                <a16:creationId xmlns:a16="http://schemas.microsoft.com/office/drawing/2014/main" id="{616EC723-59D7-4341-8399-6C1FE7134EE4}"/>
+                <a16:creationId xmlns:a16="http://schemas.microsoft.com/office/drawing/2014/main" id="{93E32347-1823-439F-AB49-62C7DCCA3167}"/>
               </a:ext>
             </a:extLst>
           </p:cNvPr>
@@ -1575,7 +1575,7 @@
           <p:cNvPr id="6" name="cover-building-band-3">
             <a:extLst xmlns:a="http://schemas.openxmlformats.org/drawingml/2006/main">
               <a:ext uri="{FF2B5EF4-FFF2-40B4-BE49-F238E27FC236}">
-                <a16:creationId xmlns:a16="http://schemas.microsoft.com/office/drawing/2014/main" id="{566D4842-B308-4274-8ED8-C03F31385E21}"/>
+                <a16:creationId xmlns:a16="http://schemas.microsoft.com/office/drawing/2014/main" id="{ADAF469D-9817-4B05-8C46-EEA1F14881CE}"/>
               </a:ext>
             </a:extLst>
           </p:cNvPr>
@@ -1606,7 +1606,7 @@
           <p:cNvPr id="7" name="cover-building-band-4">
             <a:extLst xmlns:a="http://schemas.openxmlformats.org/drawingml/2006/main">
               <a:ext uri="{FF2B5EF4-FFF2-40B4-BE49-F238E27FC236}">
-                <a16:creationId xmlns:a16="http://schemas.microsoft.com/office/drawing/2014/main" id="{F7DC4B24-D510-4E75-96FB-2C084D474DFB}"/>
+                <a16:creationId xmlns:a16="http://schemas.microsoft.com/office/drawing/2014/main" id="{6AC83AAE-E198-43AA-BDEA-982392D47265}"/>
               </a:ext>
             </a:extLst>
           </p:cNvPr>
@@ -1637,7 +1637,7 @@
           <p:cNvPr id="8" name="cover-building-band-5">
             <a:extLst xmlns:a="http://schemas.openxmlformats.org/drawingml/2006/main">
               <a:ext uri="{FF2B5EF4-FFF2-40B4-BE49-F238E27FC236}">
-                <a16:creationId xmlns:a16="http://schemas.microsoft.com/office/drawing/2014/main" id="{FBA4EC20-94DD-42D6-A100-2B66C6EF2EF0}"/>
+                <a16:creationId xmlns:a16="http://schemas.microsoft.com/office/drawing/2014/main" id="{5F3FE0F5-CD68-47B2-AE35-425F9CA8A51D}"/>
               </a:ext>
             </a:extLst>
           </p:cNvPr>
@@ -1668,7 +1668,7 @@
           <p:cNvPr id="9" name="cover-building-band-6">
             <a:extLst xmlns:a="http://schemas.openxmlformats.org/drawingml/2006/main">
               <a:ext uri="{FF2B5EF4-FFF2-40B4-BE49-F238E27FC236}">
-                <a16:creationId xmlns:a16="http://schemas.microsoft.com/office/drawing/2014/main" id="{DF32B4DF-E25C-49F7-9818-E72C39E66C18}"/>
+                <a16:creationId xmlns:a16="http://schemas.microsoft.com/office/drawing/2014/main" id="{EBC8F575-984D-4944-BBEF-447F24EB1C98}"/>
               </a:ext>
             </a:extLst>
           </p:cNvPr>
@@ -1699,7 +1699,7 @@
           <p:cNvPr id="10" name="cover-building-band-7">
             <a:extLst xmlns:a="http://schemas.openxmlformats.org/drawingml/2006/main">
               <a:ext uri="{FF2B5EF4-FFF2-40B4-BE49-F238E27FC236}">
-                <a16:creationId xmlns:a16="http://schemas.microsoft.com/office/drawing/2014/main" id="{22287ABF-1B12-4BA8-8356-15DFDD0A17AA}"/>
+                <a16:creationId xmlns:a16="http://schemas.microsoft.com/office/drawing/2014/main" id="{960ADAB1-2847-48F0-A896-BC46A5528536}"/>
               </a:ext>
             </a:extLst>
           </p:cNvPr>
@@ -1730,7 +1730,7 @@
           <p:cNvPr id="11" name="cover-building-band-8">
             <a:extLst xmlns:a="http://schemas.openxmlformats.org/drawingml/2006/main">
               <a:ext uri="{FF2B5EF4-FFF2-40B4-BE49-F238E27FC236}">
-                <a16:creationId xmlns:a16="http://schemas.microsoft.com/office/drawing/2014/main" id="{2DC6CD7F-4939-4777-BBFB-B96B191B75D7}"/>
+                <a16:creationId xmlns:a16="http://schemas.microsoft.com/office/drawing/2014/main" id="{2C79102C-28CD-409C-8654-83C2B8CA8ACB}"/>
               </a:ext>
             </a:extLst>
           </p:cNvPr>
@@ -1761,7 +1761,7 @@
           <p:cNvPr id="12" name="cover-building-band-9">
             <a:extLst xmlns:a="http://schemas.openxmlformats.org/drawingml/2006/main">
               <a:ext uri="{FF2B5EF4-FFF2-40B4-BE49-F238E27FC236}">
-                <a16:creationId xmlns:a16="http://schemas.microsoft.com/office/drawing/2014/main" id="{CF5A3362-D990-48A9-8261-034C081440F4}"/>
+                <a16:creationId xmlns:a16="http://schemas.microsoft.com/office/drawing/2014/main" id="{9564F5C1-9147-41F0-8087-33866BFDE5C0}"/>
               </a:ext>
             </a:extLst>
           </p:cNvPr>
@@ -1792,7 +1792,7 @@
           <p:cNvPr id="13" name="cover-building-band-10">
             <a:extLst xmlns:a="http://schemas.openxmlformats.org/drawingml/2006/main">
               <a:ext uri="{FF2B5EF4-FFF2-40B4-BE49-F238E27FC236}">
-                <a16:creationId xmlns:a16="http://schemas.microsoft.com/office/drawing/2014/main" id="{2B89EA86-E299-476A-A84D-C2AA93EB4E73}"/>
+                <a16:creationId xmlns:a16="http://schemas.microsoft.com/office/drawing/2014/main" id="{2837874F-94F0-4299-A3DF-180DE043D9BF}"/>
               </a:ext>
             </a:extLst>
           </p:cNvPr>
@@ -1823,7 +1823,7 @@
           <p:cNvPr id="14" name="cover-white-bottom">
             <a:extLst xmlns:a="http://schemas.openxmlformats.org/drawingml/2006/main">
               <a:ext uri="{FF2B5EF4-FFF2-40B4-BE49-F238E27FC236}">
-                <a16:creationId xmlns:a16="http://schemas.microsoft.com/office/drawing/2014/main" id="{11D1AC9D-5E7B-451E-9079-2E36DCA32C0D}"/>
+                <a16:creationId xmlns:a16="http://schemas.microsoft.com/office/drawing/2014/main" id="{E7220808-E654-4948-B274-D492F1073D2A}"/>
               </a:ext>
             </a:extLst>
           </p:cNvPr>
@@ -1854,7 +1854,7 @@
           <p:cNvPr id="15" name="cover-white-curve">
             <a:extLst xmlns:a="http://schemas.openxmlformats.org/drawingml/2006/main">
               <a:ext uri="{FF2B5EF4-FFF2-40B4-BE49-F238E27FC236}">
-                <a16:creationId xmlns:a16="http://schemas.microsoft.com/office/drawing/2014/main" id="{69EB684F-4D6F-4D34-B248-62661E3A4CC9}"/>
+                <a16:creationId xmlns:a16="http://schemas.microsoft.com/office/drawing/2014/main" id="{BE74E146-06D6-4883-BC9B-209C2F74ABE7}"/>
               </a:ext>
             </a:extLst>
           </p:cNvPr>
@@ -1885,7 +1885,7 @@
           <p:cNvPr id="16" name="cover-frame-top">
             <a:extLst xmlns:a="http://schemas.openxmlformats.org/drawingml/2006/main">
               <a:ext uri="{FF2B5EF4-FFF2-40B4-BE49-F238E27FC236}">
-                <a16:creationId xmlns:a16="http://schemas.microsoft.com/office/drawing/2014/main" id="{5C942A8F-5CD3-40A4-9224-B3481A78C542}"/>
+                <a16:creationId xmlns:a16="http://schemas.microsoft.com/office/drawing/2014/main" id="{C75D2B38-A17D-47AC-A26E-3C3F16BA5346}"/>
               </a:ext>
             </a:extLst>
           </p:cNvPr>
@@ -1916,7 +1916,7 @@
           <p:cNvPr id="17" name="cover-frame-left">
             <a:extLst xmlns:a="http://schemas.openxmlformats.org/drawingml/2006/main">
               <a:ext uri="{FF2B5EF4-FFF2-40B4-BE49-F238E27FC236}">
-                <a16:creationId xmlns:a16="http://schemas.microsoft.com/office/drawing/2014/main" id="{4C03EA1F-5C14-4011-957C-341AC1ECAE1E}"/>
+                <a16:creationId xmlns:a16="http://schemas.microsoft.com/office/drawing/2014/main" id="{46B9CBFD-DC20-4215-834A-0C33A40F95B5}"/>
               </a:ext>
             </a:extLst>
           </p:cNvPr>
@@ -1947,7 +1947,7 @@
           <p:cNvPr id="18" name="cover-frame-right">
             <a:extLst xmlns:a="http://schemas.openxmlformats.org/drawingml/2006/main">
               <a:ext uri="{FF2B5EF4-FFF2-40B4-BE49-F238E27FC236}">
-                <a16:creationId xmlns:a16="http://schemas.microsoft.com/office/drawing/2014/main" id="{8BC81ED8-503A-445B-ACA3-D0E6B91CEDD1}"/>
+                <a16:creationId xmlns:a16="http://schemas.microsoft.com/office/drawing/2014/main" id="{80226A80-AA1E-4959-AE50-214C3A5594C7}"/>
               </a:ext>
             </a:extLst>
           </p:cNvPr>
@@ -1978,7 +1978,7 @@
           <p:cNvPr id="19" name="cover-frame-bottom">
             <a:extLst xmlns:a="http://schemas.openxmlformats.org/drawingml/2006/main">
               <a:ext uri="{FF2B5EF4-FFF2-40B4-BE49-F238E27FC236}">
-                <a16:creationId xmlns:a16="http://schemas.microsoft.com/office/drawing/2014/main" id="{A48BAB45-33F4-4B21-9993-3D57853E422A}"/>
+                <a16:creationId xmlns:a16="http://schemas.microsoft.com/office/drawing/2014/main" id="{A989D893-4A68-4C44-B1F8-619E25973FC0}"/>
               </a:ext>
             </a:extLst>
           </p:cNvPr>
@@ -2009,7 +2009,7 @@
           <p:cNvPr id="20" name="cover-brand">
             <a:extLst xmlns:a="http://schemas.openxmlformats.org/drawingml/2006/main">
               <a:ext uri="{FF2B5EF4-FFF2-40B4-BE49-F238E27FC236}">
-                <a16:creationId xmlns:a16="http://schemas.microsoft.com/office/drawing/2014/main" id="{537154CE-3585-44B1-B462-F4C0AC66FDFD}"/>
+                <a16:creationId xmlns:a16="http://schemas.microsoft.com/office/drawing/2014/main" id="{CB21EECB-4AE4-4D14-80E2-FC6CB19951C0}"/>
               </a:ext>
             </a:extLst>
           </p:cNvPr>
@@ -2062,7 +2062,7 @@
           <p:cNvPr id="21" name="cover-organization">
             <a:extLst xmlns:a="http://schemas.openxmlformats.org/drawingml/2006/main">
               <a:ext uri="{FF2B5EF4-FFF2-40B4-BE49-F238E27FC236}">
-                <a16:creationId xmlns:a16="http://schemas.microsoft.com/office/drawing/2014/main" id="{AA8D7567-B8D7-4D24-A818-FE4AF63CB360}"/>
+                <a16:creationId xmlns:a16="http://schemas.microsoft.com/office/drawing/2014/main" id="{E040BFC5-6442-4138-B4F7-D5D7449D9FA4}"/>
               </a:ext>
             </a:extLst>
           </p:cNvPr>
@@ -2115,7 +2115,7 @@
           <p:cNvPr id="22" name="cover-rule-left">
             <a:extLst xmlns:a="http://schemas.openxmlformats.org/drawingml/2006/main">
               <a:ext uri="{FF2B5EF4-FFF2-40B4-BE49-F238E27FC236}">
-                <a16:creationId xmlns:a16="http://schemas.microsoft.com/office/drawing/2014/main" id="{41570D30-3790-4483-A7D0-8548D6C06D89}"/>
+                <a16:creationId xmlns:a16="http://schemas.microsoft.com/office/drawing/2014/main" id="{93D83B5F-0038-4408-96D0-E857151DC2A3}"/>
               </a:ext>
             </a:extLst>
           </p:cNvPr>
@@ -2146,7 +2146,7 @@
           <p:cNvPr id="23" name="cover-rule-right">
             <a:extLst xmlns:a="http://schemas.openxmlformats.org/drawingml/2006/main">
               <a:ext uri="{FF2B5EF4-FFF2-40B4-BE49-F238E27FC236}">
-                <a16:creationId xmlns:a16="http://schemas.microsoft.com/office/drawing/2014/main" id="{8462F875-34F5-42CB-A0B2-14A013356E1B}"/>
+                <a16:creationId xmlns:a16="http://schemas.microsoft.com/office/drawing/2014/main" id="{68F5146A-5CFF-44F1-ADE2-BF3C0A3C0D9B}"/>
               </a:ext>
             </a:extLst>
           </p:cNvPr>
@@ -2177,7 +2177,7 @@
           <p:cNvPr id="24" name="cover-title">
             <a:extLst xmlns:a="http://schemas.openxmlformats.org/drawingml/2006/main">
               <a:ext uri="{FF2B5EF4-FFF2-40B4-BE49-F238E27FC236}">
-                <a16:creationId xmlns:a16="http://schemas.microsoft.com/office/drawing/2014/main" id="{DB850EFF-F99D-4AE4-B74F-9C2D15F996E2}"/>
+                <a16:creationId xmlns:a16="http://schemas.microsoft.com/office/drawing/2014/main" id="{A90E8784-FDC8-45A5-B805-14D011894286}"/>
               </a:ext>
             </a:extLst>
           </p:cNvPr>
@@ -2230,7 +2230,7 @@
           <p:cNvPr id="25" name="cover-tagline">
             <a:extLst xmlns:a="http://schemas.openxmlformats.org/drawingml/2006/main">
               <a:ext uri="{FF2B5EF4-FFF2-40B4-BE49-F238E27FC236}">
-                <a16:creationId xmlns:a16="http://schemas.microsoft.com/office/drawing/2014/main" id="{0DDEA769-03D6-42F3-B96C-8FB9BF8BC03A}"/>
+                <a16:creationId xmlns:a16="http://schemas.microsoft.com/office/drawing/2014/main" id="{C808C601-9EFF-4C3F-BE63-781D5A27BAB9}"/>
               </a:ext>
             </a:extLst>
           </p:cNvPr>
@@ -2285,7 +2285,7 @@
           <p:cNvPr id="26" name="internal-notice">
             <a:extLst xmlns:a="http://schemas.openxmlformats.org/drawingml/2006/main">
               <a:ext uri="{FF2B5EF4-FFF2-40B4-BE49-F238E27FC236}">
-                <a16:creationId xmlns:a16="http://schemas.microsoft.com/office/drawing/2014/main" id="{90F8CF9E-2BE3-4AAE-8B18-46420A666CB9}"/>
+                <a16:creationId xmlns:a16="http://schemas.microsoft.com/office/drawing/2014/main" id="{D6F02779-1A64-4683-907D-CAB58A390D1E}"/>
               </a:ext>
             </a:extLst>
           </p:cNvPr>
@@ -2336,7 +2336,7 @@
     </p:spTree>
     <p:extLst>
       <p:ext uri="{BB962C8B-B14F-4D97-AF65-F5344CB8AC3E}">
-        <p14:creationId xmlns:p14="http://schemas.microsoft.com/office/powerpoint/2010/main" val="2026683290"/>
+        <p14:creationId xmlns:p14="http://schemas.microsoft.com/office/powerpoint/2010/main" val="959530619"/>
       </p:ext>
     </p:extLst>
   </p:cSld>
@@ -2367,7 +2367,7 @@
           <p:cNvPr id="41" name="header-shadow-line">
             <a:extLst xmlns:a="http://schemas.openxmlformats.org/drawingml/2006/main">
               <a:ext uri="{FF2B5EF4-FFF2-40B4-BE49-F238E27FC236}">
-                <a16:creationId xmlns:a16="http://schemas.microsoft.com/office/drawing/2014/main" id="{761C54A5-85BC-40BE-B551-C7327BB46AEC}"/>
+                <a16:creationId xmlns:a16="http://schemas.microsoft.com/office/drawing/2014/main" id="{3AC2647E-63D3-4C09-ACF1-ADA92704648D}"/>
               </a:ext>
             </a:extLst>
           </p:cNvPr>
@@ -2398,7 +2398,7 @@
           <p:cNvPr id="2" name="header-green-line">
             <a:extLst xmlns:a="http://schemas.openxmlformats.org/drawingml/2006/main">
               <a:ext uri="{FF2B5EF4-FFF2-40B4-BE49-F238E27FC236}">
-                <a16:creationId xmlns:a16="http://schemas.microsoft.com/office/drawing/2014/main" id="{1F059C5C-778E-4064-9D5A-D3815D4B7D7D}"/>
+                <a16:creationId xmlns:a16="http://schemas.microsoft.com/office/drawing/2014/main" id="{1D1C2869-A642-483A-8711-7A963A0C05EB}"/>
               </a:ext>
             </a:extLst>
           </p:cNvPr>
@@ -2429,7 +2429,7 @@
           <p:cNvPr id="3" name="page-number-block">
             <a:extLst xmlns:a="http://schemas.openxmlformats.org/drawingml/2006/main">
               <a:ext uri="{FF2B5EF4-FFF2-40B4-BE49-F238E27FC236}">
-                <a16:creationId xmlns:a16="http://schemas.microsoft.com/office/drawing/2014/main" id="{58928FF0-2BBE-4D06-AB37-5068B3586E22}"/>
+                <a16:creationId xmlns:a16="http://schemas.microsoft.com/office/drawing/2014/main" id="{BB40637F-0A95-4827-ACBC-A79097CB46E4}"/>
               </a:ext>
             </a:extLst>
           </p:cNvPr>
@@ -2460,7 +2460,7 @@
           <p:cNvPr id="4" name="page-number">
             <a:extLst xmlns:a="http://schemas.openxmlformats.org/drawingml/2006/main">
               <a:ext uri="{FF2B5EF4-FFF2-40B4-BE49-F238E27FC236}">
-                <a16:creationId xmlns:a16="http://schemas.microsoft.com/office/drawing/2014/main" id="{95A639D7-BB64-4028-A08F-CFBE8F37D1A1}"/>
+                <a16:creationId xmlns:a16="http://schemas.microsoft.com/office/drawing/2014/main" id="{9B5A57A4-B76A-47CE-87DD-597F3573F877}"/>
               </a:ext>
             </a:extLst>
           </p:cNvPr>
@@ -2513,7 +2513,7 @@
           <p:cNvPr id="5" name="page-title">
             <a:extLst xmlns:a="http://schemas.openxmlformats.org/drawingml/2006/main">
               <a:ext uri="{FF2B5EF4-FFF2-40B4-BE49-F238E27FC236}">
-                <a16:creationId xmlns:a16="http://schemas.microsoft.com/office/drawing/2014/main" id="{CD545A7C-0A0B-4354-BE7C-5DB12AECF181}"/>
+                <a16:creationId xmlns:a16="http://schemas.microsoft.com/office/drawing/2014/main" id="{0284E1E4-5ABE-4C1A-A684-6B6ECCFD94D2}"/>
               </a:ext>
             </a:extLst>
           </p:cNvPr>
@@ -2566,7 +2566,7 @@
           <p:cNvPr id="6" name="brand-wordmark">
             <a:extLst xmlns:a="http://schemas.openxmlformats.org/drawingml/2006/main">
               <a:ext uri="{FF2B5EF4-FFF2-40B4-BE49-F238E27FC236}">
-                <a16:creationId xmlns:a16="http://schemas.microsoft.com/office/drawing/2014/main" id="{B4B93589-0028-499C-9E3A-2439B60C0EDE}"/>
+                <a16:creationId xmlns:a16="http://schemas.microsoft.com/office/drawing/2014/main" id="{2914E371-28E7-4C84-8459-921996811D84}"/>
               </a:ext>
             </a:extLst>
           </p:cNvPr>
@@ -2619,7 +2619,7 @@
           <p:cNvPr id="7" name="internal-notice">
             <a:extLst xmlns:a="http://schemas.openxmlformats.org/drawingml/2006/main">
               <a:ext uri="{FF2B5EF4-FFF2-40B4-BE49-F238E27FC236}">
-                <a16:creationId xmlns:a16="http://schemas.microsoft.com/office/drawing/2014/main" id="{7A2A7F43-BC07-4ABD-9DBF-956F13948E97}"/>
+                <a16:creationId xmlns:a16="http://schemas.microsoft.com/office/drawing/2014/main" id="{D2F6205F-9E86-4B7D-92D6-33CD4BA4965C}"/>
               </a:ext>
             </a:extLst>
           </p:cNvPr>
@@ -2672,7 +2672,7 @@
           <p:cNvPr id="8" name="primary-packshot-surface">
             <a:extLst xmlns:a="http://schemas.openxmlformats.org/drawingml/2006/main">
               <a:ext uri="{FF2B5EF4-FFF2-40B4-BE49-F238E27FC236}">
-                <a16:creationId xmlns:a16="http://schemas.microsoft.com/office/drawing/2014/main" id="{6186B01A-574A-477F-90B7-C149C37F17FE}"/>
+                <a16:creationId xmlns:a16="http://schemas.microsoft.com/office/drawing/2014/main" id="{651D1671-F825-4A25-BB59-B74240F4B110}"/>
               </a:ext>
             </a:extLst>
           </p:cNvPr>
@@ -2705,7 +2705,7 @@
           <p:cNvPr id="9" name="primary-packshot-label">
             <a:extLst xmlns:a="http://schemas.openxmlformats.org/drawingml/2006/main">
               <a:ext uri="{FF2B5EF4-FFF2-40B4-BE49-F238E27FC236}">
-                <a16:creationId xmlns:a16="http://schemas.microsoft.com/office/drawing/2014/main" id="{A533743D-DF9D-4112-97FE-87E764124F85}"/>
+                <a16:creationId xmlns:a16="http://schemas.microsoft.com/office/drawing/2014/main" id="{71163ACE-9833-4BF1-96F9-A964E68C38E8}"/>
               </a:ext>
             </a:extLst>
           </p:cNvPr>
@@ -2778,7 +2778,7 @@
           <p:cNvPr id="10" name="product-name">
             <a:extLst xmlns:a="http://schemas.openxmlformats.org/drawingml/2006/main">
               <a:ext uri="{FF2B5EF4-FFF2-40B4-BE49-F238E27FC236}">
-                <a16:creationId xmlns:a16="http://schemas.microsoft.com/office/drawing/2014/main" id="{A37138E6-035F-493B-8A4F-DACEE46217B8}"/>
+                <a16:creationId xmlns:a16="http://schemas.microsoft.com/office/drawing/2014/main" id="{65AB2EFB-0B58-4543-A03F-F8E52E7B6D1E}"/>
               </a:ext>
             </a:extLst>
           </p:cNvPr>
@@ -2831,7 +2831,7 @@
           <p:cNvPr id="11" name="product-table-head-0-surface">
             <a:extLst xmlns:a="http://schemas.openxmlformats.org/drawingml/2006/main">
               <a:ext uri="{FF2B5EF4-FFF2-40B4-BE49-F238E27FC236}">
-                <a16:creationId xmlns:a16="http://schemas.microsoft.com/office/drawing/2014/main" id="{04023CFF-6912-4222-A53E-DE5FC6AA6F5F}"/>
+                <a16:creationId xmlns:a16="http://schemas.microsoft.com/office/drawing/2014/main" id="{B07CEB68-E28D-4BA2-8788-E24C3EF1DBED}"/>
               </a:ext>
             </a:extLst>
           </p:cNvPr>
@@ -2864,7 +2864,7 @@
           <p:cNvPr id="12" name="product-table-head-0-text">
             <a:extLst xmlns:a="http://schemas.openxmlformats.org/drawingml/2006/main">
               <a:ext uri="{FF2B5EF4-FFF2-40B4-BE49-F238E27FC236}">
-                <a16:creationId xmlns:a16="http://schemas.microsoft.com/office/drawing/2014/main" id="{51C1779C-11B5-4506-86C0-0CB1937CC15F}"/>
+                <a16:creationId xmlns:a16="http://schemas.microsoft.com/office/drawing/2014/main" id="{9562BD08-99F5-4BE8-B02B-7F791CBDA0A9}"/>
               </a:ext>
             </a:extLst>
           </p:cNvPr>
@@ -2917,7 +2917,7 @@
           <p:cNvPr id="13" name="product-table-head-1-surface">
             <a:extLst xmlns:a="http://schemas.openxmlformats.org/drawingml/2006/main">
               <a:ext uri="{FF2B5EF4-FFF2-40B4-BE49-F238E27FC236}">
-                <a16:creationId xmlns:a16="http://schemas.microsoft.com/office/drawing/2014/main" id="{E984DEFF-1197-4563-8896-A1C8917BF044}"/>
+                <a16:creationId xmlns:a16="http://schemas.microsoft.com/office/drawing/2014/main" id="{A9C334D1-52B2-4303-A2BA-7E5196879566}"/>
               </a:ext>
             </a:extLst>
           </p:cNvPr>
@@ -2950,7 +2950,7 @@
           <p:cNvPr id="14" name="product-table-head-1-text">
             <a:extLst xmlns:a="http://schemas.openxmlformats.org/drawingml/2006/main">
               <a:ext uri="{FF2B5EF4-FFF2-40B4-BE49-F238E27FC236}">
-                <a16:creationId xmlns:a16="http://schemas.microsoft.com/office/drawing/2014/main" id="{26C92935-860F-4F28-AE2C-B60D56238D37}"/>
+                <a16:creationId xmlns:a16="http://schemas.microsoft.com/office/drawing/2014/main" id="{78A08983-7DA5-465B-80E1-1AF154E8B231}"/>
               </a:ext>
             </a:extLst>
           </p:cNvPr>
@@ -3003,7 +3003,7 @@
           <p:cNvPr id="15" name="product-table-head-2-surface">
             <a:extLst xmlns:a="http://schemas.openxmlformats.org/drawingml/2006/main">
               <a:ext uri="{FF2B5EF4-FFF2-40B4-BE49-F238E27FC236}">
-                <a16:creationId xmlns:a16="http://schemas.microsoft.com/office/drawing/2014/main" id="{3DC8528C-18A0-469E-970E-2558130089FF}"/>
+                <a16:creationId xmlns:a16="http://schemas.microsoft.com/office/drawing/2014/main" id="{D2BBA36B-EF85-4100-8A3E-761E74605F0A}"/>
               </a:ext>
             </a:extLst>
           </p:cNvPr>
@@ -3036,7 +3036,7 @@
           <p:cNvPr id="16" name="product-table-head-2-text">
             <a:extLst xmlns:a="http://schemas.openxmlformats.org/drawingml/2006/main">
               <a:ext uri="{FF2B5EF4-FFF2-40B4-BE49-F238E27FC236}">
-                <a16:creationId xmlns:a16="http://schemas.microsoft.com/office/drawing/2014/main" id="{5D598DD7-6493-444C-8665-D13244F5D3B0}"/>
+                <a16:creationId xmlns:a16="http://schemas.microsoft.com/office/drawing/2014/main" id="{700D2A89-52E2-47AA-87CF-13D99FCE403D}"/>
               </a:ext>
             </a:extLst>
           </p:cNvPr>
@@ -3089,7 +3089,7 @@
           <p:cNvPr id="17" name="product-table-head-3-surface">
             <a:extLst xmlns:a="http://schemas.openxmlformats.org/drawingml/2006/main">
               <a:ext uri="{FF2B5EF4-FFF2-40B4-BE49-F238E27FC236}">
-                <a16:creationId xmlns:a16="http://schemas.microsoft.com/office/drawing/2014/main" id="{32E623CC-5478-44E0-A570-681E1982C991}"/>
+                <a16:creationId xmlns:a16="http://schemas.microsoft.com/office/drawing/2014/main" id="{5CB3DE06-AE7C-459E-A9A4-59C31719EC2D}"/>
               </a:ext>
             </a:extLst>
           </p:cNvPr>
@@ -3122,7 +3122,7 @@
           <p:cNvPr id="18" name="product-table-head-3-text">
             <a:extLst xmlns:a="http://schemas.openxmlformats.org/drawingml/2006/main">
               <a:ext uri="{FF2B5EF4-FFF2-40B4-BE49-F238E27FC236}">
-                <a16:creationId xmlns:a16="http://schemas.microsoft.com/office/drawing/2014/main" id="{15D439F4-7EED-479D-8885-09103F5F4E78}"/>
+                <a16:creationId xmlns:a16="http://schemas.microsoft.com/office/drawing/2014/main" id="{8B4A9933-5F84-4CCA-8A8F-F068297CA43C}"/>
               </a:ext>
             </a:extLst>
           </p:cNvPr>
@@ -3175,7 +3175,7 @@
           <p:cNvPr id="19" name="product-table-value-0-surface">
             <a:extLst xmlns:a="http://schemas.openxmlformats.org/drawingml/2006/main">
               <a:ext uri="{FF2B5EF4-FFF2-40B4-BE49-F238E27FC236}">
-                <a16:creationId xmlns:a16="http://schemas.microsoft.com/office/drawing/2014/main" id="{E07BB0B7-5A95-4E29-B6BC-75E93F186A5E}"/>
+                <a16:creationId xmlns:a16="http://schemas.microsoft.com/office/drawing/2014/main" id="{36ACBC85-A8DC-4255-BA22-9903CB57E414}"/>
               </a:ext>
             </a:extLst>
           </p:cNvPr>
@@ -3208,7 +3208,7 @@
           <p:cNvPr id="20" name="product-table-value-0-text">
             <a:extLst xmlns:a="http://schemas.openxmlformats.org/drawingml/2006/main">
               <a:ext uri="{FF2B5EF4-FFF2-40B4-BE49-F238E27FC236}">
-                <a16:creationId xmlns:a16="http://schemas.microsoft.com/office/drawing/2014/main" id="{48E2FF3F-6493-45E3-9C69-4419114FF8C1}"/>
+                <a16:creationId xmlns:a16="http://schemas.microsoft.com/office/drawing/2014/main" id="{FFEEFD15-741C-4F8F-896C-D6FDB8F47885}"/>
               </a:ext>
             </a:extLst>
           </p:cNvPr>
@@ -3261,7 +3261,7 @@
           <p:cNvPr id="21" name="product-table-value-1-surface">
             <a:extLst xmlns:a="http://schemas.openxmlformats.org/drawingml/2006/main">
               <a:ext uri="{FF2B5EF4-FFF2-40B4-BE49-F238E27FC236}">
-                <a16:creationId xmlns:a16="http://schemas.microsoft.com/office/drawing/2014/main" id="{A7CDD28B-92F6-488E-8B39-AB1DC0A8A6E4}"/>
+                <a16:creationId xmlns:a16="http://schemas.microsoft.com/office/drawing/2014/main" id="{DF5E4EF0-DFDE-4289-9A25-CA3639D940CF}"/>
               </a:ext>
             </a:extLst>
           </p:cNvPr>
@@ -3294,7 +3294,7 @@
           <p:cNvPr id="22" name="product-table-value-1-text">
             <a:extLst xmlns:a="http://schemas.openxmlformats.org/drawingml/2006/main">
               <a:ext uri="{FF2B5EF4-FFF2-40B4-BE49-F238E27FC236}">
-                <a16:creationId xmlns:a16="http://schemas.microsoft.com/office/drawing/2014/main" id="{AB8BEE93-08BB-4255-8AE0-76B04430C24A}"/>
+                <a16:creationId xmlns:a16="http://schemas.microsoft.com/office/drawing/2014/main" id="{EE1827C4-698B-47BB-BA64-534DC2D437E2}"/>
               </a:ext>
             </a:extLst>
           </p:cNvPr>
@@ -3347,7 +3347,7 @@
           <p:cNvPr id="23" name="product-table-value-2-surface">
             <a:extLst xmlns:a="http://schemas.openxmlformats.org/drawingml/2006/main">
               <a:ext uri="{FF2B5EF4-FFF2-40B4-BE49-F238E27FC236}">
-                <a16:creationId xmlns:a16="http://schemas.microsoft.com/office/drawing/2014/main" id="{47898786-9441-4532-A5D6-A1B64FD6E190}"/>
+                <a16:creationId xmlns:a16="http://schemas.microsoft.com/office/drawing/2014/main" id="{E929B07B-6336-4CD5-9229-D88479E8E452}"/>
               </a:ext>
             </a:extLst>
           </p:cNvPr>
@@ -3380,7 +3380,7 @@
           <p:cNvPr id="24" name="product-table-value-2-text">
             <a:extLst xmlns:a="http://schemas.openxmlformats.org/drawingml/2006/main">
               <a:ext uri="{FF2B5EF4-FFF2-40B4-BE49-F238E27FC236}">
-                <a16:creationId xmlns:a16="http://schemas.microsoft.com/office/drawing/2014/main" id="{A644D3A2-5B08-4675-A3D1-79843598453D}"/>
+                <a16:creationId xmlns:a16="http://schemas.microsoft.com/office/drawing/2014/main" id="{070E24D8-3F7D-458E-82C7-D10827EBF6DD}"/>
               </a:ext>
             </a:extLst>
           </p:cNvPr>
@@ -3433,7 +3433,7 @@
           <p:cNvPr id="25" name="product-table-value-3-surface">
             <a:extLst xmlns:a="http://schemas.openxmlformats.org/drawingml/2006/main">
               <a:ext uri="{FF2B5EF4-FFF2-40B4-BE49-F238E27FC236}">
-                <a16:creationId xmlns:a16="http://schemas.microsoft.com/office/drawing/2014/main" id="{0F35C511-A708-4082-9AEF-4C86647797F3}"/>
+                <a16:creationId xmlns:a16="http://schemas.microsoft.com/office/drawing/2014/main" id="{AD5A38ED-DBB1-410B-8437-61B38E291A87}"/>
               </a:ext>
             </a:extLst>
           </p:cNvPr>
@@ -3466,7 +3466,7 @@
           <p:cNvPr id="26" name="product-table-value-3-text">
             <a:extLst xmlns:a="http://schemas.openxmlformats.org/drawingml/2006/main">
               <a:ext uri="{FF2B5EF4-FFF2-40B4-BE49-F238E27FC236}">
-                <a16:creationId xmlns:a16="http://schemas.microsoft.com/office/drawing/2014/main" id="{16DF90C8-7928-4387-8F19-03357013280D}"/>
+                <a16:creationId xmlns:a16="http://schemas.microsoft.com/office/drawing/2014/main" id="{BF834963-461B-4F62-8000-DEA295EBFE13}"/>
               </a:ext>
             </a:extLst>
           </p:cNvPr>
@@ -3519,7 +3519,7 @@
           <p:cNvPr id="27" name="selling-point-highlight">
             <a:extLst xmlns:a="http://schemas.openxmlformats.org/drawingml/2006/main">
               <a:ext uri="{FF2B5EF4-FFF2-40B4-BE49-F238E27FC236}">
-                <a16:creationId xmlns:a16="http://schemas.microsoft.com/office/drawing/2014/main" id="{09CB82D2-9D6E-4420-B9D6-1FA65EE5DF28}"/>
+                <a16:creationId xmlns:a16="http://schemas.microsoft.com/office/drawing/2014/main" id="{29EA4A5A-87AE-4858-B1CD-647E57C56CF5}"/>
               </a:ext>
             </a:extLst>
           </p:cNvPr>
@@ -3550,7 +3550,7 @@
           <p:cNvPr id="28" name="selling-point">
             <a:extLst xmlns:a="http://schemas.openxmlformats.org/drawingml/2006/main">
               <a:ext uri="{FF2B5EF4-FFF2-40B4-BE49-F238E27FC236}">
-                <a16:creationId xmlns:a16="http://schemas.microsoft.com/office/drawing/2014/main" id="{0D25C0EB-1F5C-4EE3-8C87-C491AB2A9B1F}"/>
+                <a16:creationId xmlns:a16="http://schemas.microsoft.com/office/drawing/2014/main" id="{F0D09D03-914F-4E12-9989-2F5C1DE8B49C}"/>
               </a:ext>
             </a:extLst>
           </p:cNvPr>
@@ -3603,7 +3603,7 @@
           <p:cNvPr id="29" name="section-title-0">
             <a:extLst xmlns:a="http://schemas.openxmlformats.org/drawingml/2006/main">
               <a:ext uri="{FF2B5EF4-FFF2-40B4-BE49-F238E27FC236}">
-                <a16:creationId xmlns:a16="http://schemas.microsoft.com/office/drawing/2014/main" id="{1D5F43E7-5C24-4F4B-A468-DB45A0D34969}"/>
+                <a16:creationId xmlns:a16="http://schemas.microsoft.com/office/drawing/2014/main" id="{8931EF60-506D-403B-B6A7-5EDAC3C5F430}"/>
               </a:ext>
             </a:extLst>
           </p:cNvPr>
@@ -3658,7 +3658,7 @@
           <p:cNvPr id="30" name="section-0-item-0">
             <a:extLst xmlns:a="http://schemas.openxmlformats.org/drawingml/2006/main">
               <a:ext uri="{FF2B5EF4-FFF2-40B4-BE49-F238E27FC236}">
-                <a16:creationId xmlns:a16="http://schemas.microsoft.com/office/drawing/2014/main" id="{D86FCB80-3606-4DAF-AC5A-BBA0CF508854}"/>
+                <a16:creationId xmlns:a16="http://schemas.microsoft.com/office/drawing/2014/main" id="{63A26BB1-213E-499E-ACE5-4994195EA1B1}"/>
               </a:ext>
             </a:extLst>
           </p:cNvPr>
@@ -3711,7 +3711,7 @@
           <p:cNvPr id="31" name="section-0-item-1">
             <a:extLst xmlns:a="http://schemas.openxmlformats.org/drawingml/2006/main">
               <a:ext uri="{FF2B5EF4-FFF2-40B4-BE49-F238E27FC236}">
-                <a16:creationId xmlns:a16="http://schemas.microsoft.com/office/drawing/2014/main" id="{AD86478C-1975-4CEA-AA92-9E2DEE8F75E5}"/>
+                <a16:creationId xmlns:a16="http://schemas.microsoft.com/office/drawing/2014/main" id="{FDA24C82-0A94-4797-BD0D-6EF2EC620E8D}"/>
               </a:ext>
             </a:extLst>
           </p:cNvPr>
@@ -3764,7 +3764,7 @@
           <p:cNvPr id="32" name="section-0-item-2">
             <a:extLst xmlns:a="http://schemas.openxmlformats.org/drawingml/2006/main">
               <a:ext uri="{FF2B5EF4-FFF2-40B4-BE49-F238E27FC236}">
-                <a16:creationId xmlns:a16="http://schemas.microsoft.com/office/drawing/2014/main" id="{7081E902-E760-463B-8778-0CC2D29BF9D4}"/>
+                <a16:creationId xmlns:a16="http://schemas.microsoft.com/office/drawing/2014/main" id="{8BA5D8D5-D570-4A7E-B809-A3D72D0C1AB7}"/>
               </a:ext>
             </a:extLst>
           </p:cNvPr>
@@ -3817,7 +3817,7 @@
           <p:cNvPr id="33" name="section-title-1">
             <a:extLst xmlns:a="http://schemas.openxmlformats.org/drawingml/2006/main">
               <a:ext uri="{FF2B5EF4-FFF2-40B4-BE49-F238E27FC236}">
-                <a16:creationId xmlns:a16="http://schemas.microsoft.com/office/drawing/2014/main" id="{C5570F48-4417-4814-9E7F-C64131C0CE86}"/>
+                <a16:creationId xmlns:a16="http://schemas.microsoft.com/office/drawing/2014/main" id="{D22ADF62-A90B-4772-989F-CF77CED8C564}"/>
               </a:ext>
             </a:extLst>
           </p:cNvPr>
@@ -3872,7 +3872,7 @@
           <p:cNvPr id="34" name="section-1-item-0">
             <a:extLst xmlns:a="http://schemas.openxmlformats.org/drawingml/2006/main">
               <a:ext uri="{FF2B5EF4-FFF2-40B4-BE49-F238E27FC236}">
-                <a16:creationId xmlns:a16="http://schemas.microsoft.com/office/drawing/2014/main" id="{23C3E8CF-ED86-493C-9C52-E5C6A20F0B36}"/>
+                <a16:creationId xmlns:a16="http://schemas.microsoft.com/office/drawing/2014/main" id="{AACB0BB4-4C62-417B-8A9B-05AA0BFFD644}"/>
               </a:ext>
             </a:extLst>
           </p:cNvPr>
@@ -3925,7 +3925,7 @@
           <p:cNvPr id="35" name="section-1-item-1">
             <a:extLst xmlns:a="http://schemas.openxmlformats.org/drawingml/2006/main">
               <a:ext uri="{FF2B5EF4-FFF2-40B4-BE49-F238E27FC236}">
-                <a16:creationId xmlns:a16="http://schemas.microsoft.com/office/drawing/2014/main" id="{68ADBEAD-3DD5-4AB6-BDF0-76AAF42B37B0}"/>
+                <a16:creationId xmlns:a16="http://schemas.microsoft.com/office/drawing/2014/main" id="{5A923B51-511A-4A81-9F6C-E10D6FAC5418}"/>
               </a:ext>
             </a:extLst>
           </p:cNvPr>
@@ -3978,7 +3978,7 @@
           <p:cNvPr id="36" name="section-1-item-2">
             <a:extLst xmlns:a="http://schemas.openxmlformats.org/drawingml/2006/main">
               <a:ext uri="{FF2B5EF4-FFF2-40B4-BE49-F238E27FC236}">
-                <a16:creationId xmlns:a16="http://schemas.microsoft.com/office/drawing/2014/main" id="{F108EE80-6D8F-4F58-955A-74E41A4656F4}"/>
+                <a16:creationId xmlns:a16="http://schemas.microsoft.com/office/drawing/2014/main" id="{C120F104-F7A2-454D-A753-45F9825C0741}"/>
               </a:ext>
             </a:extLst>
           </p:cNvPr>
@@ -4031,7 +4031,7 @@
           <p:cNvPr id="37" name="section-title-2">
             <a:extLst xmlns:a="http://schemas.openxmlformats.org/drawingml/2006/main">
               <a:ext uri="{FF2B5EF4-FFF2-40B4-BE49-F238E27FC236}">
-                <a16:creationId xmlns:a16="http://schemas.microsoft.com/office/drawing/2014/main" id="{9A756446-8F7B-454A-A5DA-93B072DC3F10}"/>
+                <a16:creationId xmlns:a16="http://schemas.microsoft.com/office/drawing/2014/main" id="{ECC4CD24-34C9-4806-8D44-FC61BDE2D49B}"/>
               </a:ext>
             </a:extLst>
           </p:cNvPr>
@@ -4086,7 +4086,7 @@
           <p:cNvPr id="38" name="section-2-item-0">
             <a:extLst xmlns:a="http://schemas.openxmlformats.org/drawingml/2006/main">
               <a:ext uri="{FF2B5EF4-FFF2-40B4-BE49-F238E27FC236}">
-                <a16:creationId xmlns:a16="http://schemas.microsoft.com/office/drawing/2014/main" id="{88486483-BF46-4FA7-9117-9351B576A050}"/>
+                <a16:creationId xmlns:a16="http://schemas.microsoft.com/office/drawing/2014/main" id="{B3DF0C22-4314-4E77-B6A2-7E6840BC76CF}"/>
               </a:ext>
             </a:extLst>
           </p:cNvPr>
@@ -4139,7 +4139,7 @@
           <p:cNvPr id="39" name="section-2-item-1">
             <a:extLst xmlns:a="http://schemas.openxmlformats.org/drawingml/2006/main">
               <a:ext uri="{FF2B5EF4-FFF2-40B4-BE49-F238E27FC236}">
-                <a16:creationId xmlns:a16="http://schemas.microsoft.com/office/drawing/2014/main" id="{3CDC0715-D21C-4BD9-9318-8CF4656C90EF}"/>
+                <a16:creationId xmlns:a16="http://schemas.microsoft.com/office/drawing/2014/main" id="{4E9EA74D-B4C0-49C4-A6DD-082AA89C718B}"/>
               </a:ext>
             </a:extLst>
           </p:cNvPr>
@@ -4192,7 +4192,7 @@
           <p:cNvPr id="40" name="section-2-item-2">
             <a:extLst xmlns:a="http://schemas.openxmlformats.org/drawingml/2006/main">
               <a:ext uri="{FF2B5EF4-FFF2-40B4-BE49-F238E27FC236}">
-                <a16:creationId xmlns:a16="http://schemas.microsoft.com/office/drawing/2014/main" id="{81296B87-7B22-4FE2-86F6-012AE80C61B0}"/>
+                <a16:creationId xmlns:a16="http://schemas.microsoft.com/office/drawing/2014/main" id="{97CA60AC-6B88-42E7-8C64-D1E1C5F3FCCB}"/>
               </a:ext>
             </a:extLst>
           </p:cNvPr>
@@ -4243,7 +4243,7 @@
     </p:spTree>
     <p:extLst>
       <p:ext uri="{BB962C8B-B14F-4D97-AF65-F5344CB8AC3E}">
-        <p14:creationId xmlns:p14="http://schemas.microsoft.com/office/powerpoint/2010/main" val="224996214"/>
+        <p14:creationId xmlns:p14="http://schemas.microsoft.com/office/powerpoint/2010/main" val="888957987"/>
       </p:ext>
     </p:extLst>
   </p:cSld>
@@ -4274,7 +4274,7 @@
           <p:cNvPr id="50" name="header-shadow-line">
             <a:extLst xmlns:a="http://schemas.openxmlformats.org/drawingml/2006/main">
               <a:ext uri="{FF2B5EF4-FFF2-40B4-BE49-F238E27FC236}">
-                <a16:creationId xmlns:a16="http://schemas.microsoft.com/office/drawing/2014/main" id="{AE3A4CEE-39F9-4423-B5AE-9BFA23C6012A}"/>
+                <a16:creationId xmlns:a16="http://schemas.microsoft.com/office/drawing/2014/main" id="{F3028CBF-ABDD-4DE5-A114-058D14D1C1C7}"/>
               </a:ext>
             </a:extLst>
           </p:cNvPr>
@@ -4305,7 +4305,7 @@
           <p:cNvPr id="2" name="header-green-line">
             <a:extLst xmlns:a="http://schemas.openxmlformats.org/drawingml/2006/main">
               <a:ext uri="{FF2B5EF4-FFF2-40B4-BE49-F238E27FC236}">
-                <a16:creationId xmlns:a16="http://schemas.microsoft.com/office/drawing/2014/main" id="{DC81A3B1-770F-4C71-9539-0917BE5E4F1E}"/>
+                <a16:creationId xmlns:a16="http://schemas.microsoft.com/office/drawing/2014/main" id="{46BC8110-18CF-427E-B127-5AF7DA7DDD7A}"/>
               </a:ext>
             </a:extLst>
           </p:cNvPr>
@@ -4336,7 +4336,7 @@
           <p:cNvPr id="3" name="page-number-block">
             <a:extLst xmlns:a="http://schemas.openxmlformats.org/drawingml/2006/main">
               <a:ext uri="{FF2B5EF4-FFF2-40B4-BE49-F238E27FC236}">
-                <a16:creationId xmlns:a16="http://schemas.microsoft.com/office/drawing/2014/main" id="{BAE93B90-07E7-4E50-8843-67214789D8CA}"/>
+                <a16:creationId xmlns:a16="http://schemas.microsoft.com/office/drawing/2014/main" id="{D36101B8-0A0C-42E0-B689-10335F0DFAEA}"/>
               </a:ext>
             </a:extLst>
           </p:cNvPr>
@@ -4367,7 +4367,7 @@
           <p:cNvPr id="4" name="page-number">
             <a:extLst xmlns:a="http://schemas.openxmlformats.org/drawingml/2006/main">
               <a:ext uri="{FF2B5EF4-FFF2-40B4-BE49-F238E27FC236}">
-                <a16:creationId xmlns:a16="http://schemas.microsoft.com/office/drawing/2014/main" id="{1A429E8C-B883-4A1F-BE92-D66DCDD20CA5}"/>
+                <a16:creationId xmlns:a16="http://schemas.microsoft.com/office/drawing/2014/main" id="{2031D0D1-9CD6-4838-8476-FC6DA2F728C2}"/>
               </a:ext>
             </a:extLst>
           </p:cNvPr>
@@ -4420,7 +4420,7 @@
           <p:cNvPr id="5" name="page-title">
             <a:extLst xmlns:a="http://schemas.openxmlformats.org/drawingml/2006/main">
               <a:ext uri="{FF2B5EF4-FFF2-40B4-BE49-F238E27FC236}">
-                <a16:creationId xmlns:a16="http://schemas.microsoft.com/office/drawing/2014/main" id="{2B3EA4D4-D153-4815-A375-6EA31CD4ACE4}"/>
+                <a16:creationId xmlns:a16="http://schemas.microsoft.com/office/drawing/2014/main" id="{BFFC1D44-508F-4C47-8E95-3579E1A23EC9}"/>
               </a:ext>
             </a:extLst>
           </p:cNvPr>
@@ -4473,7 +4473,7 @@
           <p:cNvPr id="6" name="brand-wordmark">
             <a:extLst xmlns:a="http://schemas.openxmlformats.org/drawingml/2006/main">
               <a:ext uri="{FF2B5EF4-FFF2-40B4-BE49-F238E27FC236}">
-                <a16:creationId xmlns:a16="http://schemas.microsoft.com/office/drawing/2014/main" id="{52469A3F-89ED-441D-8CC1-B5AED850CBA0}"/>
+                <a16:creationId xmlns:a16="http://schemas.microsoft.com/office/drawing/2014/main" id="{954A0761-9B74-4185-B3EF-FDDE06F47CCC}"/>
               </a:ext>
             </a:extLst>
           </p:cNvPr>
@@ -4526,7 +4526,7 @@
           <p:cNvPr id="7" name="internal-notice">
             <a:extLst xmlns:a="http://schemas.openxmlformats.org/drawingml/2006/main">
               <a:ext uri="{FF2B5EF4-FFF2-40B4-BE49-F238E27FC236}">
-                <a16:creationId xmlns:a16="http://schemas.microsoft.com/office/drawing/2014/main" id="{74DF481B-9CD2-4781-A12A-632030F2EB3F}"/>
+                <a16:creationId xmlns:a16="http://schemas.microsoft.com/office/drawing/2014/main" id="{7A6531C2-230F-4DD6-BC2B-6A4C0855F354}"/>
               </a:ext>
             </a:extLst>
           </p:cNvPr>
@@ -4579,7 +4579,7 @@
           <p:cNvPr id="8" name="combination-head-0-surface">
             <a:extLst xmlns:a="http://schemas.openxmlformats.org/drawingml/2006/main">
               <a:ext uri="{FF2B5EF4-FFF2-40B4-BE49-F238E27FC236}">
-                <a16:creationId xmlns:a16="http://schemas.microsoft.com/office/drawing/2014/main" id="{EB57DE1F-DFFC-4125-B3E4-FC4D86D83DC7}"/>
+                <a16:creationId xmlns:a16="http://schemas.microsoft.com/office/drawing/2014/main" id="{CFE034DF-89B7-42D9-8777-0A1A81310153}"/>
               </a:ext>
             </a:extLst>
           </p:cNvPr>
@@ -4612,7 +4612,7 @@
           <p:cNvPr id="9" name="combination-head-0-text">
             <a:extLst xmlns:a="http://schemas.openxmlformats.org/drawingml/2006/main">
               <a:ext uri="{FF2B5EF4-FFF2-40B4-BE49-F238E27FC236}">
-                <a16:creationId xmlns:a16="http://schemas.microsoft.com/office/drawing/2014/main" id="{1F948C75-160D-447B-AE83-E53901C4DD1E}"/>
+                <a16:creationId xmlns:a16="http://schemas.microsoft.com/office/drawing/2014/main" id="{20D4DD8A-FDE6-400A-BCC1-5D3F6958CE86}"/>
               </a:ext>
             </a:extLst>
           </p:cNvPr>
@@ -4665,7 +4665,7 @@
           <p:cNvPr id="10" name="combination-head-1-surface">
             <a:extLst xmlns:a="http://schemas.openxmlformats.org/drawingml/2006/main">
               <a:ext uri="{FF2B5EF4-FFF2-40B4-BE49-F238E27FC236}">
-                <a16:creationId xmlns:a16="http://schemas.microsoft.com/office/drawing/2014/main" id="{EFC808C9-920C-45E4-B079-046AD09F51EE}"/>
+                <a16:creationId xmlns:a16="http://schemas.microsoft.com/office/drawing/2014/main" id="{E13FABDA-8936-4B60-910D-6EF770952AA6}"/>
               </a:ext>
             </a:extLst>
           </p:cNvPr>
@@ -4698,7 +4698,7 @@
           <p:cNvPr id="11" name="combination-head-1-text">
             <a:extLst xmlns:a="http://schemas.openxmlformats.org/drawingml/2006/main">
               <a:ext uri="{FF2B5EF4-FFF2-40B4-BE49-F238E27FC236}">
-                <a16:creationId xmlns:a16="http://schemas.microsoft.com/office/drawing/2014/main" id="{9BCFE6BF-70C1-4FBF-8B41-EDDD645B34F2}"/>
+                <a16:creationId xmlns:a16="http://schemas.microsoft.com/office/drawing/2014/main" id="{2D6B04F4-DD21-4931-B3D8-47DCADE929F8}"/>
               </a:ext>
             </a:extLst>
           </p:cNvPr>
@@ -4751,7 +4751,7 @@
           <p:cNvPr id="12" name="combination-head-2-surface">
             <a:extLst xmlns:a="http://schemas.openxmlformats.org/drawingml/2006/main">
               <a:ext uri="{FF2B5EF4-FFF2-40B4-BE49-F238E27FC236}">
-                <a16:creationId xmlns:a16="http://schemas.microsoft.com/office/drawing/2014/main" id="{541F4BED-CD05-4D98-879B-641C505D9106}"/>
+                <a16:creationId xmlns:a16="http://schemas.microsoft.com/office/drawing/2014/main" id="{C139B00E-537F-4BCC-BAC1-1E5FE095F4BD}"/>
               </a:ext>
             </a:extLst>
           </p:cNvPr>
@@ -4784,7 +4784,7 @@
           <p:cNvPr id="13" name="combination-head-2-text">
             <a:extLst xmlns:a="http://schemas.openxmlformats.org/drawingml/2006/main">
               <a:ext uri="{FF2B5EF4-FFF2-40B4-BE49-F238E27FC236}">
-                <a16:creationId xmlns:a16="http://schemas.microsoft.com/office/drawing/2014/main" id="{485C4BAE-0517-499F-8B3B-CBC8BE25A9D1}"/>
+                <a16:creationId xmlns:a16="http://schemas.microsoft.com/office/drawing/2014/main" id="{EB55DBB5-1951-4A57-A4A3-F426C334D9C3}"/>
               </a:ext>
             </a:extLst>
           </p:cNvPr>
@@ -4837,7 +4837,7 @@
           <p:cNvPr id="14" name="combination-head-3-surface">
             <a:extLst xmlns:a="http://schemas.openxmlformats.org/drawingml/2006/main">
               <a:ext uri="{FF2B5EF4-FFF2-40B4-BE49-F238E27FC236}">
-                <a16:creationId xmlns:a16="http://schemas.microsoft.com/office/drawing/2014/main" id="{AFD9F094-5EAD-4AF4-96B4-DAD76D4C2BEC}"/>
+                <a16:creationId xmlns:a16="http://schemas.microsoft.com/office/drawing/2014/main" id="{74B64EA7-667F-4945-BDE0-4740154A75F0}"/>
               </a:ext>
             </a:extLst>
           </p:cNvPr>
@@ -4870,7 +4870,7 @@
           <p:cNvPr id="15" name="combination-head-3-text">
             <a:extLst xmlns:a="http://schemas.openxmlformats.org/drawingml/2006/main">
               <a:ext uri="{FF2B5EF4-FFF2-40B4-BE49-F238E27FC236}">
-                <a16:creationId xmlns:a16="http://schemas.microsoft.com/office/drawing/2014/main" id="{26082DFA-4736-4CEA-A203-85F18C20951D}"/>
+                <a16:creationId xmlns:a16="http://schemas.microsoft.com/office/drawing/2014/main" id="{E5A2F92B-966B-4750-BB8B-DAF19DDA39DE}"/>
               </a:ext>
             </a:extLst>
           </p:cNvPr>
@@ -4923,7 +4923,7 @@
           <p:cNvPr id="16" name="combination-head-4-surface">
             <a:extLst xmlns:a="http://schemas.openxmlformats.org/drawingml/2006/main">
               <a:ext uri="{FF2B5EF4-FFF2-40B4-BE49-F238E27FC236}">
-                <a16:creationId xmlns:a16="http://schemas.microsoft.com/office/drawing/2014/main" id="{422EE94B-BE7B-4460-85BC-30BA74142943}"/>
+                <a16:creationId xmlns:a16="http://schemas.microsoft.com/office/drawing/2014/main" id="{7AEA13FA-B226-401D-9333-4AD58208865D}"/>
               </a:ext>
             </a:extLst>
           </p:cNvPr>
@@ -4956,7 +4956,7 @@
           <p:cNvPr id="17" name="combination-head-4-text">
             <a:extLst xmlns:a="http://schemas.openxmlformats.org/drawingml/2006/main">
               <a:ext uri="{FF2B5EF4-FFF2-40B4-BE49-F238E27FC236}">
-                <a16:creationId xmlns:a16="http://schemas.microsoft.com/office/drawing/2014/main" id="{5A69FAEB-58B6-4161-AC9C-E1A62F4C824D}"/>
+                <a16:creationId xmlns:a16="http://schemas.microsoft.com/office/drawing/2014/main" id="{D2D7E454-4C56-4B34-A24C-059FD373993E}"/>
               </a:ext>
             </a:extLst>
           </p:cNvPr>
@@ -5009,7 +5009,7 @@
           <p:cNvPr id="18" name="combination-scenario-0-surface">
             <a:extLst xmlns:a="http://schemas.openxmlformats.org/drawingml/2006/main">
               <a:ext uri="{FF2B5EF4-FFF2-40B4-BE49-F238E27FC236}">
-                <a16:creationId xmlns:a16="http://schemas.microsoft.com/office/drawing/2014/main" id="{6C204B76-7AC7-4757-AF8F-A55437289870}"/>
+                <a16:creationId xmlns:a16="http://schemas.microsoft.com/office/drawing/2014/main" id="{7D7B4A89-78E8-49EC-A4B3-F3CF20A3FEB3}"/>
               </a:ext>
             </a:extLst>
           </p:cNvPr>
@@ -5042,7 +5042,7 @@
           <p:cNvPr id="19" name="combination-scenario-0-text">
             <a:extLst xmlns:a="http://schemas.openxmlformats.org/drawingml/2006/main">
               <a:ext uri="{FF2B5EF4-FFF2-40B4-BE49-F238E27FC236}">
-                <a16:creationId xmlns:a16="http://schemas.microsoft.com/office/drawing/2014/main" id="{2AEF1B93-01D7-438D-8D58-227C09B1407A}"/>
+                <a16:creationId xmlns:a16="http://schemas.microsoft.com/office/drawing/2014/main" id="{7397024A-ED98-4247-B92F-243C3F7D1F76}"/>
               </a:ext>
             </a:extLst>
           </p:cNvPr>
@@ -5095,7 +5095,7 @@
           <p:cNvPr id="20" name="combination-name-0-surface">
             <a:extLst xmlns:a="http://schemas.openxmlformats.org/drawingml/2006/main">
               <a:ext uri="{FF2B5EF4-FFF2-40B4-BE49-F238E27FC236}">
-                <a16:creationId xmlns:a16="http://schemas.microsoft.com/office/drawing/2014/main" id="{4A29D59A-30F1-4E2E-925D-41B3E9489FA0}"/>
+                <a16:creationId xmlns:a16="http://schemas.microsoft.com/office/drawing/2014/main" id="{987A99CF-2F75-464C-B900-471929C5B8A9}"/>
               </a:ext>
             </a:extLst>
           </p:cNvPr>
@@ -5128,7 +5128,7 @@
           <p:cNvPr id="21" name="combination-name-0-text">
             <a:extLst xmlns:a="http://schemas.openxmlformats.org/drawingml/2006/main">
               <a:ext uri="{FF2B5EF4-FFF2-40B4-BE49-F238E27FC236}">
-                <a16:creationId xmlns:a16="http://schemas.microsoft.com/office/drawing/2014/main" id="{7B967269-E0C5-4306-9D20-ECC7262202EB}"/>
+                <a16:creationId xmlns:a16="http://schemas.microsoft.com/office/drawing/2014/main" id="{2319CA68-6488-488F-8253-41505F4CA237}"/>
               </a:ext>
             </a:extLst>
           </p:cNvPr>
@@ -5181,7 +5181,7 @@
           <p:cNvPr id="22" name="combination-partner-surface-0">
             <a:extLst xmlns:a="http://schemas.openxmlformats.org/drawingml/2006/main">
               <a:ext uri="{FF2B5EF4-FFF2-40B4-BE49-F238E27FC236}">
-                <a16:creationId xmlns:a16="http://schemas.microsoft.com/office/drawing/2014/main" id="{2F56E9FC-690E-408A-A13E-8DA68B73D924}"/>
+                <a16:creationId xmlns:a16="http://schemas.microsoft.com/office/drawing/2014/main" id="{F14978EA-8526-4919-AA51-8032CAA3E14B}"/>
               </a:ext>
             </a:extLst>
           </p:cNvPr>
@@ -5214,7 +5214,7 @@
           <p:cNvPr id="23" name="partner-slot-0-surface">
             <a:extLst xmlns:a="http://schemas.openxmlformats.org/drawingml/2006/main">
               <a:ext uri="{FF2B5EF4-FFF2-40B4-BE49-F238E27FC236}">
-                <a16:creationId xmlns:a16="http://schemas.microsoft.com/office/drawing/2014/main" id="{0E07151B-72B0-4A2B-B6B4-102F70BE2E3E}"/>
+                <a16:creationId xmlns:a16="http://schemas.microsoft.com/office/drawing/2014/main" id="{23F60573-A963-4732-9ADF-9FDF49439F3C}"/>
               </a:ext>
             </a:extLst>
           </p:cNvPr>
@@ -5247,7 +5247,7 @@
           <p:cNvPr id="24" name="partner-slot-0-label">
             <a:extLst xmlns:a="http://schemas.openxmlformats.org/drawingml/2006/main">
               <a:ext uri="{FF2B5EF4-FFF2-40B4-BE49-F238E27FC236}">
-                <a16:creationId xmlns:a16="http://schemas.microsoft.com/office/drawing/2014/main" id="{9F8BF22E-1E3B-4DAC-82F4-E831D63D80D4}"/>
+                <a16:creationId xmlns:a16="http://schemas.microsoft.com/office/drawing/2014/main" id="{6D4B2A28-D83D-47B3-96AF-641CAA6AC8A5}"/>
               </a:ext>
             </a:extLst>
           </p:cNvPr>
@@ -5320,7 +5320,7 @@
           <p:cNvPr id="25" name="combination-talk-0-surface">
             <a:extLst xmlns:a="http://schemas.openxmlformats.org/drawingml/2006/main">
               <a:ext uri="{FF2B5EF4-FFF2-40B4-BE49-F238E27FC236}">
-                <a16:creationId xmlns:a16="http://schemas.microsoft.com/office/drawing/2014/main" id="{9930D964-065D-40CC-8D80-469F47CE41EA}"/>
+                <a16:creationId xmlns:a16="http://schemas.microsoft.com/office/drawing/2014/main" id="{13007818-0977-4AE4-BF63-9334C0F41AF1}"/>
               </a:ext>
             </a:extLst>
           </p:cNvPr>
@@ -5353,7 +5353,7 @@
           <p:cNvPr id="26" name="combination-talk-0-text">
             <a:extLst xmlns:a="http://schemas.openxmlformats.org/drawingml/2006/main">
               <a:ext uri="{FF2B5EF4-FFF2-40B4-BE49-F238E27FC236}">
-                <a16:creationId xmlns:a16="http://schemas.microsoft.com/office/drawing/2014/main" id="{BE94919D-C4A3-452E-9F55-E7718207D118}"/>
+                <a16:creationId xmlns:a16="http://schemas.microsoft.com/office/drawing/2014/main" id="{E4372ADE-33FC-44D0-ACB3-6B83FF5AF621}"/>
               </a:ext>
             </a:extLst>
           </p:cNvPr>
@@ -5406,7 +5406,7 @@
           <p:cNvPr id="27" name="combination-scenario-1-surface">
             <a:extLst xmlns:a="http://schemas.openxmlformats.org/drawingml/2006/main">
               <a:ext uri="{FF2B5EF4-FFF2-40B4-BE49-F238E27FC236}">
-                <a16:creationId xmlns:a16="http://schemas.microsoft.com/office/drawing/2014/main" id="{28386CB9-98D3-4B7B-93A9-70F046E246C0}"/>
+                <a16:creationId xmlns:a16="http://schemas.microsoft.com/office/drawing/2014/main" id="{C4EF9334-EF48-4E35-8ED5-7A023EC6C136}"/>
               </a:ext>
             </a:extLst>
           </p:cNvPr>
@@ -5439,7 +5439,7 @@
           <p:cNvPr id="28" name="combination-scenario-1-text">
             <a:extLst xmlns:a="http://schemas.openxmlformats.org/drawingml/2006/main">
               <a:ext uri="{FF2B5EF4-FFF2-40B4-BE49-F238E27FC236}">
-                <a16:creationId xmlns:a16="http://schemas.microsoft.com/office/drawing/2014/main" id="{29F4E923-CC03-4CDE-A52F-F6AADDA8C7B4}"/>
+                <a16:creationId xmlns:a16="http://schemas.microsoft.com/office/drawing/2014/main" id="{3BA24BB2-6EE1-41A9-AA6F-BF8FA779F822}"/>
               </a:ext>
             </a:extLst>
           </p:cNvPr>
@@ -5492,7 +5492,7 @@
           <p:cNvPr id="29" name="combination-name-1-surface">
             <a:extLst xmlns:a="http://schemas.openxmlformats.org/drawingml/2006/main">
               <a:ext uri="{FF2B5EF4-FFF2-40B4-BE49-F238E27FC236}">
-                <a16:creationId xmlns:a16="http://schemas.microsoft.com/office/drawing/2014/main" id="{7532D44F-241F-4D78-A834-C86F7A5ADA5E}"/>
+                <a16:creationId xmlns:a16="http://schemas.microsoft.com/office/drawing/2014/main" id="{320020A1-957E-4C1B-8FDC-A72A7ADC2ACE}"/>
               </a:ext>
             </a:extLst>
           </p:cNvPr>
@@ -5525,7 +5525,7 @@
           <p:cNvPr id="30" name="combination-name-1-text">
             <a:extLst xmlns:a="http://schemas.openxmlformats.org/drawingml/2006/main">
               <a:ext uri="{FF2B5EF4-FFF2-40B4-BE49-F238E27FC236}">
-                <a16:creationId xmlns:a16="http://schemas.microsoft.com/office/drawing/2014/main" id="{2AC3C892-DC4C-435E-83D1-F362DEA1D57E}"/>
+                <a16:creationId xmlns:a16="http://schemas.microsoft.com/office/drawing/2014/main" id="{40E6DB3D-52D6-41A4-BD68-1B7ABDD1BF18}"/>
               </a:ext>
             </a:extLst>
           </p:cNvPr>
@@ -5578,7 +5578,7 @@
           <p:cNvPr id="31" name="combination-partner-surface-1">
             <a:extLst xmlns:a="http://schemas.openxmlformats.org/drawingml/2006/main">
               <a:ext uri="{FF2B5EF4-FFF2-40B4-BE49-F238E27FC236}">
-                <a16:creationId xmlns:a16="http://schemas.microsoft.com/office/drawing/2014/main" id="{23D38D02-7E22-4893-9CAA-831D97BE2622}"/>
+                <a16:creationId xmlns:a16="http://schemas.microsoft.com/office/drawing/2014/main" id="{03F50EB9-1D41-49A1-B6AA-51B578B50B84}"/>
               </a:ext>
             </a:extLst>
           </p:cNvPr>
@@ -5611,7 +5611,7 @@
           <p:cNvPr id="32" name="partner-slot-1-surface">
             <a:extLst xmlns:a="http://schemas.openxmlformats.org/drawingml/2006/main">
               <a:ext uri="{FF2B5EF4-FFF2-40B4-BE49-F238E27FC236}">
-                <a16:creationId xmlns:a16="http://schemas.microsoft.com/office/drawing/2014/main" id="{010E2CCA-018F-4CFF-8A2C-B2480BAF24CD}"/>
+                <a16:creationId xmlns:a16="http://schemas.microsoft.com/office/drawing/2014/main" id="{A94B0D61-20DF-4BF0-939B-E9F72AFD1031}"/>
               </a:ext>
             </a:extLst>
           </p:cNvPr>
@@ -5644,7 +5644,7 @@
           <p:cNvPr id="33" name="partner-slot-1-label">
             <a:extLst xmlns:a="http://schemas.openxmlformats.org/drawingml/2006/main">
               <a:ext uri="{FF2B5EF4-FFF2-40B4-BE49-F238E27FC236}">
-                <a16:creationId xmlns:a16="http://schemas.microsoft.com/office/drawing/2014/main" id="{13E80BEA-1106-4639-8133-372BA70C1A0A}"/>
+                <a16:creationId xmlns:a16="http://schemas.microsoft.com/office/drawing/2014/main" id="{22DD06FD-9E7E-493C-B21D-E8E20DB5E724}"/>
               </a:ext>
             </a:extLst>
           </p:cNvPr>
@@ -5717,7 +5717,7 @@
           <p:cNvPr id="34" name="combination-talk-1-surface">
             <a:extLst xmlns:a="http://schemas.openxmlformats.org/drawingml/2006/main">
               <a:ext uri="{FF2B5EF4-FFF2-40B4-BE49-F238E27FC236}">
-                <a16:creationId xmlns:a16="http://schemas.microsoft.com/office/drawing/2014/main" id="{A94E041B-A8E2-4354-B9DF-1A9B916965E9}"/>
+                <a16:creationId xmlns:a16="http://schemas.microsoft.com/office/drawing/2014/main" id="{A5B5237D-8F3C-49DE-B834-CCAEBD0289FD}"/>
               </a:ext>
             </a:extLst>
           </p:cNvPr>
@@ -5750,7 +5750,7 @@
           <p:cNvPr id="35" name="combination-talk-1-text">
             <a:extLst xmlns:a="http://schemas.openxmlformats.org/drawingml/2006/main">
               <a:ext uri="{FF2B5EF4-FFF2-40B4-BE49-F238E27FC236}">
-                <a16:creationId xmlns:a16="http://schemas.microsoft.com/office/drawing/2014/main" id="{833D3EE8-7825-4485-8058-7600EA765CFB}"/>
+                <a16:creationId xmlns:a16="http://schemas.microsoft.com/office/drawing/2014/main" id="{3F6149B3-DF30-4229-AD73-1801564208D3}"/>
               </a:ext>
             </a:extLst>
           </p:cNvPr>
@@ -5803,7 +5803,7 @@
           <p:cNvPr id="36" name="combination-scenario-2-surface">
             <a:extLst xmlns:a="http://schemas.openxmlformats.org/drawingml/2006/main">
               <a:ext uri="{FF2B5EF4-FFF2-40B4-BE49-F238E27FC236}">
-                <a16:creationId xmlns:a16="http://schemas.microsoft.com/office/drawing/2014/main" id="{C7D79AD2-1BC3-46C4-95DF-E6DB9155BCB6}"/>
+                <a16:creationId xmlns:a16="http://schemas.microsoft.com/office/drawing/2014/main" id="{11BD32C0-38C4-4B4E-A1F3-B9705365624C}"/>
               </a:ext>
             </a:extLst>
           </p:cNvPr>
@@ -5836,7 +5836,7 @@
           <p:cNvPr id="37" name="combination-scenario-2-text">
             <a:extLst xmlns:a="http://schemas.openxmlformats.org/drawingml/2006/main">
               <a:ext uri="{FF2B5EF4-FFF2-40B4-BE49-F238E27FC236}">
-                <a16:creationId xmlns:a16="http://schemas.microsoft.com/office/drawing/2014/main" id="{AFE2E3E3-C309-40A4-87CB-E8DF14121B30}"/>
+                <a16:creationId xmlns:a16="http://schemas.microsoft.com/office/drawing/2014/main" id="{F2BEB556-32CE-470A-B476-0B21DE75825E}"/>
               </a:ext>
             </a:extLst>
           </p:cNvPr>
@@ -5889,7 +5889,7 @@
           <p:cNvPr id="38" name="combination-name-2-surface">
             <a:extLst xmlns:a="http://schemas.openxmlformats.org/drawingml/2006/main">
               <a:ext uri="{FF2B5EF4-FFF2-40B4-BE49-F238E27FC236}">
-                <a16:creationId xmlns:a16="http://schemas.microsoft.com/office/drawing/2014/main" id="{F477D51A-AF59-4A23-8624-3AF1BFCB4267}"/>
+                <a16:creationId xmlns:a16="http://schemas.microsoft.com/office/drawing/2014/main" id="{E1E4082A-1D7F-4882-8B37-5BAB2E6981D5}"/>
               </a:ext>
             </a:extLst>
           </p:cNvPr>
@@ -5922,7 +5922,7 @@
           <p:cNvPr id="39" name="combination-name-2-text">
             <a:extLst xmlns:a="http://schemas.openxmlformats.org/drawingml/2006/main">
               <a:ext uri="{FF2B5EF4-FFF2-40B4-BE49-F238E27FC236}">
-                <a16:creationId xmlns:a16="http://schemas.microsoft.com/office/drawing/2014/main" id="{06633851-75B5-49D3-8264-DB85DA9A07BC}"/>
+                <a16:creationId xmlns:a16="http://schemas.microsoft.com/office/drawing/2014/main" id="{9C56F9CC-3971-4872-96D0-D9E3612ABC52}"/>
               </a:ext>
             </a:extLst>
           </p:cNvPr>
@@ -5975,7 +5975,7 @@
           <p:cNvPr id="40" name="combination-partner-surface-2">
             <a:extLst xmlns:a="http://schemas.openxmlformats.org/drawingml/2006/main">
               <a:ext uri="{FF2B5EF4-FFF2-40B4-BE49-F238E27FC236}">
-                <a16:creationId xmlns:a16="http://schemas.microsoft.com/office/drawing/2014/main" id="{57488CDF-E23F-4A10-960C-0A2CEF9A4E81}"/>
+                <a16:creationId xmlns:a16="http://schemas.microsoft.com/office/drawing/2014/main" id="{72A609B9-AB03-432B-920D-89750BBDBCCE}"/>
               </a:ext>
             </a:extLst>
           </p:cNvPr>
@@ -6008,7 +6008,7 @@
           <p:cNvPr id="41" name="partner-slot-2-surface">
             <a:extLst xmlns:a="http://schemas.openxmlformats.org/drawingml/2006/main">
               <a:ext uri="{FF2B5EF4-FFF2-40B4-BE49-F238E27FC236}">
-                <a16:creationId xmlns:a16="http://schemas.microsoft.com/office/drawing/2014/main" id="{D8777EF8-45E3-4D81-93BB-ABB332C8A292}"/>
+                <a16:creationId xmlns:a16="http://schemas.microsoft.com/office/drawing/2014/main" id="{8F86CCA1-52D1-48AE-B9F7-9F501D1CDC0B}"/>
               </a:ext>
             </a:extLst>
           </p:cNvPr>
@@ -6041,7 +6041,7 @@
           <p:cNvPr id="42" name="partner-slot-2-label">
             <a:extLst xmlns:a="http://schemas.openxmlformats.org/drawingml/2006/main">
               <a:ext uri="{FF2B5EF4-FFF2-40B4-BE49-F238E27FC236}">
-                <a16:creationId xmlns:a16="http://schemas.microsoft.com/office/drawing/2014/main" id="{A9B8E702-A930-4F93-A727-D9E6834E8BCC}"/>
+                <a16:creationId xmlns:a16="http://schemas.microsoft.com/office/drawing/2014/main" id="{9DFFBB5F-0843-499E-852E-553047777ED5}"/>
               </a:ext>
             </a:extLst>
           </p:cNvPr>
@@ -6114,7 +6114,7 @@
           <p:cNvPr id="43" name="combination-talk-2-surface">
             <a:extLst xmlns:a="http://schemas.openxmlformats.org/drawingml/2006/main">
               <a:ext uri="{FF2B5EF4-FFF2-40B4-BE49-F238E27FC236}">
-                <a16:creationId xmlns:a16="http://schemas.microsoft.com/office/drawing/2014/main" id="{A1B3AE75-A846-4066-AE22-4F2C7CF0852B}"/>
+                <a16:creationId xmlns:a16="http://schemas.microsoft.com/office/drawing/2014/main" id="{9A02948E-DC00-4076-B431-FC38798BABB4}"/>
               </a:ext>
             </a:extLst>
           </p:cNvPr>
@@ -6147,7 +6147,7 @@
           <p:cNvPr id="44" name="combination-talk-2-text">
             <a:extLst xmlns:a="http://schemas.openxmlformats.org/drawingml/2006/main">
               <a:ext uri="{FF2B5EF4-FFF2-40B4-BE49-F238E27FC236}">
-                <a16:creationId xmlns:a16="http://schemas.microsoft.com/office/drawing/2014/main" id="{14584591-CAE1-4EC9-92F0-0E8FBA4BA89E}"/>
+                <a16:creationId xmlns:a16="http://schemas.microsoft.com/office/drawing/2014/main" id="{97F75554-9245-40FB-8BBF-C545F675B878}"/>
               </a:ext>
             </a:extLst>
           </p:cNvPr>
@@ -6200,7 +6200,7 @@
           <p:cNvPr id="45" name="combination-primary-merge-surface">
             <a:extLst xmlns:a="http://schemas.openxmlformats.org/drawingml/2006/main">
               <a:ext uri="{FF2B5EF4-FFF2-40B4-BE49-F238E27FC236}">
-                <a16:creationId xmlns:a16="http://schemas.microsoft.com/office/drawing/2014/main" id="{792E75C5-F2ED-4C0C-84F8-8209DF34E0C2}"/>
+                <a16:creationId xmlns:a16="http://schemas.microsoft.com/office/drawing/2014/main" id="{B972EA83-F9FC-4D3A-A952-B743077B1F60}"/>
               </a:ext>
             </a:extLst>
           </p:cNvPr>
@@ -6233,7 +6233,7 @@
           <p:cNvPr id="46" name="combination-primary-divider">
             <a:extLst xmlns:a="http://schemas.openxmlformats.org/drawingml/2006/main">
               <a:ext uri="{FF2B5EF4-FFF2-40B4-BE49-F238E27FC236}">
-                <a16:creationId xmlns:a16="http://schemas.microsoft.com/office/drawing/2014/main" id="{ED303674-8D54-4F6F-8442-736D44813577}"/>
+                <a16:creationId xmlns:a16="http://schemas.microsoft.com/office/drawing/2014/main" id="{9459A425-333D-44B0-A929-8559F681CF6C}"/>
               </a:ext>
             </a:extLst>
           </p:cNvPr>
@@ -6264,7 +6264,7 @@
           <p:cNvPr id="47" name="combination-plus">
             <a:extLst xmlns:a="http://schemas.openxmlformats.org/drawingml/2006/main">
               <a:ext uri="{FF2B5EF4-FFF2-40B4-BE49-F238E27FC236}">
-                <a16:creationId xmlns:a16="http://schemas.microsoft.com/office/drawing/2014/main" id="{C42B370A-504F-4E02-BC0F-688AE3976856}"/>
+                <a16:creationId xmlns:a16="http://schemas.microsoft.com/office/drawing/2014/main" id="{651AA28D-B211-4558-A1E9-1C44B264707E}"/>
               </a:ext>
             </a:extLst>
           </p:cNvPr>
@@ -6317,7 +6317,7 @@
           <p:cNvPr id="48" name="combination-primary-product-surface">
             <a:extLst xmlns:a="http://schemas.openxmlformats.org/drawingml/2006/main">
               <a:ext uri="{FF2B5EF4-FFF2-40B4-BE49-F238E27FC236}">
-                <a16:creationId xmlns:a16="http://schemas.microsoft.com/office/drawing/2014/main" id="{6995CE37-11CB-4C56-8382-0D09ABD61A90}"/>
+                <a16:creationId xmlns:a16="http://schemas.microsoft.com/office/drawing/2014/main" id="{0EF9ED74-EBF0-44D0-9778-623827283816}"/>
               </a:ext>
             </a:extLst>
           </p:cNvPr>
@@ -6350,7 +6350,7 @@
           <p:cNvPr id="49" name="combination-primary-product-label">
             <a:extLst xmlns:a="http://schemas.openxmlformats.org/drawingml/2006/main">
               <a:ext uri="{FF2B5EF4-FFF2-40B4-BE49-F238E27FC236}">
-                <a16:creationId xmlns:a16="http://schemas.microsoft.com/office/drawing/2014/main" id="{0AC73A51-F5B7-4227-AB87-518A7AA5DB96}"/>
+                <a16:creationId xmlns:a16="http://schemas.microsoft.com/office/drawing/2014/main" id="{018EA3BC-42DE-4131-A967-3A0CBBCC46A0}"/>
               </a:ext>
             </a:extLst>
           </p:cNvPr>
@@ -6421,7 +6421,7 @@
     </p:spTree>
     <p:extLst>
       <p:ext uri="{BB962C8B-B14F-4D97-AF65-F5344CB8AC3E}">
-        <p14:creationId xmlns:p14="http://schemas.microsoft.com/office/powerpoint/2010/main" val="700284087"/>
+        <p14:creationId xmlns:p14="http://schemas.microsoft.com/office/powerpoint/2010/main" val="259707909"/>
       </p:ext>
     </p:extLst>
   </p:cSld>
@@ -6452,7 +6452,7 @@
           <p:cNvPr id="42" name="header-shadow-line">
             <a:extLst xmlns:a="http://schemas.openxmlformats.org/drawingml/2006/main">
               <a:ext uri="{FF2B5EF4-FFF2-40B4-BE49-F238E27FC236}">
-                <a16:creationId xmlns:a16="http://schemas.microsoft.com/office/drawing/2014/main" id="{DC3F69CE-0280-4DB0-B72F-39AE57DC9DD9}"/>
+                <a16:creationId xmlns:a16="http://schemas.microsoft.com/office/drawing/2014/main" id="{20332979-083C-43B3-948B-BEC39A5D9CE6}"/>
               </a:ext>
             </a:extLst>
           </p:cNvPr>
@@ -6483,7 +6483,7 @@
           <p:cNvPr id="2" name="header-green-line">
             <a:extLst xmlns:a="http://schemas.openxmlformats.org/drawingml/2006/main">
               <a:ext uri="{FF2B5EF4-FFF2-40B4-BE49-F238E27FC236}">
-                <a16:creationId xmlns:a16="http://schemas.microsoft.com/office/drawing/2014/main" id="{22D9E253-35CD-4F79-BA0C-57DB3F7B1069}"/>
+                <a16:creationId xmlns:a16="http://schemas.microsoft.com/office/drawing/2014/main" id="{16B3C0D3-041B-4472-8CDF-803B794B3313}"/>
               </a:ext>
             </a:extLst>
           </p:cNvPr>
@@ -6514,7 +6514,7 @@
           <p:cNvPr id="3" name="page-number-block">
             <a:extLst xmlns:a="http://schemas.openxmlformats.org/drawingml/2006/main">
               <a:ext uri="{FF2B5EF4-FFF2-40B4-BE49-F238E27FC236}">
-                <a16:creationId xmlns:a16="http://schemas.microsoft.com/office/drawing/2014/main" id="{0F890E6C-B98E-476D-A282-A1436AAA2E30}"/>
+                <a16:creationId xmlns:a16="http://schemas.microsoft.com/office/drawing/2014/main" id="{D64FAB19-1D6C-4504-9BCA-9F931F617640}"/>
               </a:ext>
             </a:extLst>
           </p:cNvPr>
@@ -6545,7 +6545,7 @@
           <p:cNvPr id="4" name="page-number">
             <a:extLst xmlns:a="http://schemas.openxmlformats.org/drawingml/2006/main">
               <a:ext uri="{FF2B5EF4-FFF2-40B4-BE49-F238E27FC236}">
-                <a16:creationId xmlns:a16="http://schemas.microsoft.com/office/drawing/2014/main" id="{EC181753-DBF7-4AD4-8AE7-653A80A6E183}"/>
+                <a16:creationId xmlns:a16="http://schemas.microsoft.com/office/drawing/2014/main" id="{299E9EB3-B6F4-4470-9BC2-76A82B0EDCCE}"/>
               </a:ext>
             </a:extLst>
           </p:cNvPr>
@@ -6598,7 +6598,7 @@
           <p:cNvPr id="5" name="page-title">
             <a:extLst xmlns:a="http://schemas.openxmlformats.org/drawingml/2006/main">
               <a:ext uri="{FF2B5EF4-FFF2-40B4-BE49-F238E27FC236}">
-                <a16:creationId xmlns:a16="http://schemas.microsoft.com/office/drawing/2014/main" id="{7DB7262B-35DE-4DAF-942B-5CC2205B3DD9}"/>
+                <a16:creationId xmlns:a16="http://schemas.microsoft.com/office/drawing/2014/main" id="{5588174D-5A15-4166-9EE6-14A46411840E}"/>
               </a:ext>
             </a:extLst>
           </p:cNvPr>
@@ -6651,7 +6651,7 @@
           <p:cNvPr id="6" name="brand-wordmark">
             <a:extLst xmlns:a="http://schemas.openxmlformats.org/drawingml/2006/main">
               <a:ext uri="{FF2B5EF4-FFF2-40B4-BE49-F238E27FC236}">
-                <a16:creationId xmlns:a16="http://schemas.microsoft.com/office/drawing/2014/main" id="{D8F9C872-58DD-4C00-BB82-50CA23AC2965}"/>
+                <a16:creationId xmlns:a16="http://schemas.microsoft.com/office/drawing/2014/main" id="{56089812-5CE1-443B-9023-3F5F0FF49154}"/>
               </a:ext>
             </a:extLst>
           </p:cNvPr>
@@ -6704,7 +6704,7 @@
           <p:cNvPr id="7" name="internal-notice">
             <a:extLst xmlns:a="http://schemas.openxmlformats.org/drawingml/2006/main">
               <a:ext uri="{FF2B5EF4-FFF2-40B4-BE49-F238E27FC236}">
-                <a16:creationId xmlns:a16="http://schemas.microsoft.com/office/drawing/2014/main" id="{AB89C3D0-E564-47D4-AB61-458C8E2F6FA5}"/>
+                <a16:creationId xmlns:a16="http://schemas.microsoft.com/office/drawing/2014/main" id="{276BA87D-0213-4FD4-BF82-E41551714488}"/>
               </a:ext>
             </a:extLst>
           </p:cNvPr>
@@ -6757,7 +6757,7 @@
           <p:cNvPr id="8" name="benchmark-head-0-surface">
             <a:extLst xmlns:a="http://schemas.openxmlformats.org/drawingml/2006/main">
               <a:ext uri="{FF2B5EF4-FFF2-40B4-BE49-F238E27FC236}">
-                <a16:creationId xmlns:a16="http://schemas.microsoft.com/office/drawing/2014/main" id="{EB0FEA3C-9161-4351-9930-C2152634E997}"/>
+                <a16:creationId xmlns:a16="http://schemas.microsoft.com/office/drawing/2014/main" id="{6FF0AC2C-8063-481B-ACC1-9EE7B373EAC0}"/>
               </a:ext>
             </a:extLst>
           </p:cNvPr>
@@ -6790,7 +6790,7 @@
           <p:cNvPr id="9" name="benchmark-head-0-text">
             <a:extLst xmlns:a="http://schemas.openxmlformats.org/drawingml/2006/main">
               <a:ext uri="{FF2B5EF4-FFF2-40B4-BE49-F238E27FC236}">
-                <a16:creationId xmlns:a16="http://schemas.microsoft.com/office/drawing/2014/main" id="{12432136-2364-457B-9E3A-6EEECDE03D80}"/>
+                <a16:creationId xmlns:a16="http://schemas.microsoft.com/office/drawing/2014/main" id="{D420D62B-074F-4927-B532-BBA761AFD073}"/>
               </a:ext>
             </a:extLst>
           </p:cNvPr>
@@ -6843,7 +6843,7 @@
           <p:cNvPr id="10" name="benchmark-head-1-surface">
             <a:extLst xmlns:a="http://schemas.openxmlformats.org/drawingml/2006/main">
               <a:ext uri="{FF2B5EF4-FFF2-40B4-BE49-F238E27FC236}">
-                <a16:creationId xmlns:a16="http://schemas.microsoft.com/office/drawing/2014/main" id="{935D851E-7AC7-4B36-8A1C-265884D49955}"/>
+                <a16:creationId xmlns:a16="http://schemas.microsoft.com/office/drawing/2014/main" id="{80234700-60A2-451E-A438-67B7D49B9832}"/>
               </a:ext>
             </a:extLst>
           </p:cNvPr>
@@ -6876,7 +6876,7 @@
           <p:cNvPr id="11" name="benchmark-head-1-text">
             <a:extLst xmlns:a="http://schemas.openxmlformats.org/drawingml/2006/main">
               <a:ext uri="{FF2B5EF4-FFF2-40B4-BE49-F238E27FC236}">
-                <a16:creationId xmlns:a16="http://schemas.microsoft.com/office/drawing/2014/main" id="{42DA3EB0-EC47-4D0A-A949-F6A937C9BEF3}"/>
+                <a16:creationId xmlns:a16="http://schemas.microsoft.com/office/drawing/2014/main" id="{A63CE258-B3AF-47CC-919E-C114D26D6631}"/>
               </a:ext>
             </a:extLst>
           </p:cNvPr>
@@ -6929,7 +6929,7 @@
           <p:cNvPr id="12" name="benchmark-head-2-surface">
             <a:extLst xmlns:a="http://schemas.openxmlformats.org/drawingml/2006/main">
               <a:ext uri="{FF2B5EF4-FFF2-40B4-BE49-F238E27FC236}">
-                <a16:creationId xmlns:a16="http://schemas.microsoft.com/office/drawing/2014/main" id="{EEE051CA-73C3-4E0C-8220-B0663D32989A}"/>
+                <a16:creationId xmlns:a16="http://schemas.microsoft.com/office/drawing/2014/main" id="{D91134F2-6A04-4C83-B631-7549F5A69E45}"/>
               </a:ext>
             </a:extLst>
           </p:cNvPr>
@@ -6962,7 +6962,7 @@
           <p:cNvPr id="13" name="benchmark-head-2-text">
             <a:extLst xmlns:a="http://schemas.openxmlformats.org/drawingml/2006/main">
               <a:ext uri="{FF2B5EF4-FFF2-40B4-BE49-F238E27FC236}">
-                <a16:creationId xmlns:a16="http://schemas.microsoft.com/office/drawing/2014/main" id="{1ABAB97B-71F4-4AC7-BBB3-BC95A0BDC755}"/>
+                <a16:creationId xmlns:a16="http://schemas.microsoft.com/office/drawing/2014/main" id="{F33C258C-A1A3-40FE-A634-8984DD1A37C4}"/>
               </a:ext>
             </a:extLst>
           </p:cNvPr>
@@ -7015,7 +7015,7 @@
           <p:cNvPr id="14" name="benchmark-label-0-surface">
             <a:extLst xmlns:a="http://schemas.openxmlformats.org/drawingml/2006/main">
               <a:ext uri="{FF2B5EF4-FFF2-40B4-BE49-F238E27FC236}">
-                <a16:creationId xmlns:a16="http://schemas.microsoft.com/office/drawing/2014/main" id="{127286C2-DCBD-4A3D-8F92-427B7090887D}"/>
+                <a16:creationId xmlns:a16="http://schemas.microsoft.com/office/drawing/2014/main" id="{808146D0-A93F-4938-972F-E0EEFB73EF8A}"/>
               </a:ext>
             </a:extLst>
           </p:cNvPr>
@@ -7048,7 +7048,7 @@
           <p:cNvPr id="15" name="benchmark-label-0-text">
             <a:extLst xmlns:a="http://schemas.openxmlformats.org/drawingml/2006/main">
               <a:ext uri="{FF2B5EF4-FFF2-40B4-BE49-F238E27FC236}">
-                <a16:creationId xmlns:a16="http://schemas.microsoft.com/office/drawing/2014/main" id="{5C364A86-1C11-446B-88D0-C43D7CEDECD3}"/>
+                <a16:creationId xmlns:a16="http://schemas.microsoft.com/office/drawing/2014/main" id="{65A50B08-1CE2-44B3-ADEB-BAC8780F1748}"/>
               </a:ext>
             </a:extLst>
           </p:cNvPr>
@@ -7101,7 +7101,7 @@
           <p:cNvPr id="16" name="benchmark-product-left-cell">
             <a:extLst xmlns:a="http://schemas.openxmlformats.org/drawingml/2006/main">
               <a:ext uri="{FF2B5EF4-FFF2-40B4-BE49-F238E27FC236}">
-                <a16:creationId xmlns:a16="http://schemas.microsoft.com/office/drawing/2014/main" id="{D5E12809-6DFF-41D7-87B1-C660705F31D8}"/>
+                <a16:creationId xmlns:a16="http://schemas.microsoft.com/office/drawing/2014/main" id="{D73D4219-5B0C-40CF-8D22-8AD9B1113148}"/>
               </a:ext>
             </a:extLst>
           </p:cNvPr>
@@ -7134,7 +7134,7 @@
           <p:cNvPr id="17" name="benchmark-product-right-cell">
             <a:extLst xmlns:a="http://schemas.openxmlformats.org/drawingml/2006/main">
               <a:ext uri="{FF2B5EF4-FFF2-40B4-BE49-F238E27FC236}">
-                <a16:creationId xmlns:a16="http://schemas.microsoft.com/office/drawing/2014/main" id="{A676687F-4FDB-46C4-9B38-F77748EFF32A}"/>
+                <a16:creationId xmlns:a16="http://schemas.microsoft.com/office/drawing/2014/main" id="{789EC4A0-6A4D-46BD-900A-0A6DB9885C0D}"/>
               </a:ext>
             </a:extLst>
           </p:cNvPr>
@@ -7167,7 +7167,7 @@
           <p:cNvPr id="18" name="benchmark-primary-packshot-surface">
             <a:extLst xmlns:a="http://schemas.openxmlformats.org/drawingml/2006/main">
               <a:ext uri="{FF2B5EF4-FFF2-40B4-BE49-F238E27FC236}">
-                <a16:creationId xmlns:a16="http://schemas.microsoft.com/office/drawing/2014/main" id="{9C823811-F25B-4B80-B2B0-FF12A303DA79}"/>
+                <a16:creationId xmlns:a16="http://schemas.microsoft.com/office/drawing/2014/main" id="{8EEB00A9-4B27-4AFB-83F9-BBE9FF0AF414}"/>
               </a:ext>
             </a:extLst>
           </p:cNvPr>
@@ -7200,7 +7200,7 @@
           <p:cNvPr id="19" name="benchmark-primary-packshot-label">
             <a:extLst xmlns:a="http://schemas.openxmlformats.org/drawingml/2006/main">
               <a:ext uri="{FF2B5EF4-FFF2-40B4-BE49-F238E27FC236}">
-                <a16:creationId xmlns:a16="http://schemas.microsoft.com/office/drawing/2014/main" id="{14C59D85-5361-4DE2-916E-FE619A75CF26}"/>
+                <a16:creationId xmlns:a16="http://schemas.microsoft.com/office/drawing/2014/main" id="{B0E2D792-6515-4B31-8105-F94BE1639316}"/>
               </a:ext>
             </a:extLst>
           </p:cNvPr>
@@ -7273,7 +7273,7 @@
           <p:cNvPr id="20" name="benchmark-competitor-packshot-surface">
             <a:extLst xmlns:a="http://schemas.openxmlformats.org/drawingml/2006/main">
               <a:ext uri="{FF2B5EF4-FFF2-40B4-BE49-F238E27FC236}">
-                <a16:creationId xmlns:a16="http://schemas.microsoft.com/office/drawing/2014/main" id="{1A1500C2-E7BB-4F19-8289-92BDC0E788EA}"/>
+                <a16:creationId xmlns:a16="http://schemas.microsoft.com/office/drawing/2014/main" id="{0C17CA9F-3A07-4C93-8778-F881BD4829DC}"/>
               </a:ext>
             </a:extLst>
           </p:cNvPr>
@@ -7306,7 +7306,7 @@
           <p:cNvPr id="21" name="benchmark-competitor-packshot-label">
             <a:extLst xmlns:a="http://schemas.openxmlformats.org/drawingml/2006/main">
               <a:ext uri="{FF2B5EF4-FFF2-40B4-BE49-F238E27FC236}">
-                <a16:creationId xmlns:a16="http://schemas.microsoft.com/office/drawing/2014/main" id="{4F80370F-AD26-4959-83D3-21DC15F2F9B3}"/>
+                <a16:creationId xmlns:a16="http://schemas.microsoft.com/office/drawing/2014/main" id="{6581F36C-F8D7-4C67-8E6E-CD6EE7E121EE}"/>
               </a:ext>
             </a:extLst>
           </p:cNvPr>
@@ -7379,7 +7379,7 @@
           <p:cNvPr id="22" name="benchmark-label-1-surface">
             <a:extLst xmlns:a="http://schemas.openxmlformats.org/drawingml/2006/main">
               <a:ext uri="{FF2B5EF4-FFF2-40B4-BE49-F238E27FC236}">
-                <a16:creationId xmlns:a16="http://schemas.microsoft.com/office/drawing/2014/main" id="{A2577484-5230-409F-A079-27F13C12C3FD}"/>
+                <a16:creationId xmlns:a16="http://schemas.microsoft.com/office/drawing/2014/main" id="{02F062C0-71B4-413F-8734-8E8ADA18D54A}"/>
               </a:ext>
             </a:extLst>
           </p:cNvPr>
@@ -7412,7 +7412,7 @@
           <p:cNvPr id="23" name="benchmark-label-1-text">
             <a:extLst xmlns:a="http://schemas.openxmlformats.org/drawingml/2006/main">
               <a:ext uri="{FF2B5EF4-FFF2-40B4-BE49-F238E27FC236}">
-                <a16:creationId xmlns:a16="http://schemas.microsoft.com/office/drawing/2014/main" id="{87EB4463-9429-41DE-9A49-42588C5010A7}"/>
+                <a16:creationId xmlns:a16="http://schemas.microsoft.com/office/drawing/2014/main" id="{F472A183-0E4C-4C56-A465-D0473BAE3C10}"/>
               </a:ext>
             </a:extLst>
           </p:cNvPr>
@@ -7465,7 +7465,7 @@
           <p:cNvPr id="24" name="benchmark-merged-1-surface">
             <a:extLst xmlns:a="http://schemas.openxmlformats.org/drawingml/2006/main">
               <a:ext uri="{FF2B5EF4-FFF2-40B4-BE49-F238E27FC236}">
-                <a16:creationId xmlns:a16="http://schemas.microsoft.com/office/drawing/2014/main" id="{296766B9-3B12-4EC2-97EE-2C7C1BCF3589}"/>
+                <a16:creationId xmlns:a16="http://schemas.microsoft.com/office/drawing/2014/main" id="{337A8204-E689-49D1-B526-EC221BA25325}"/>
               </a:ext>
             </a:extLst>
           </p:cNvPr>
@@ -7498,7 +7498,7 @@
           <p:cNvPr id="25" name="benchmark-merged-1-text">
             <a:extLst xmlns:a="http://schemas.openxmlformats.org/drawingml/2006/main">
               <a:ext uri="{FF2B5EF4-FFF2-40B4-BE49-F238E27FC236}">
-                <a16:creationId xmlns:a16="http://schemas.microsoft.com/office/drawing/2014/main" id="{D7A4CE03-C02D-4FAD-83DE-D119A7DBB628}"/>
+                <a16:creationId xmlns:a16="http://schemas.microsoft.com/office/drawing/2014/main" id="{EB340492-BA0A-49D2-9C32-AB727DC02CFD}"/>
               </a:ext>
             </a:extLst>
           </p:cNvPr>
@@ -7551,7 +7551,7 @@
           <p:cNvPr id="26" name="benchmark-label-2-surface">
             <a:extLst xmlns:a="http://schemas.openxmlformats.org/drawingml/2006/main">
               <a:ext uri="{FF2B5EF4-FFF2-40B4-BE49-F238E27FC236}">
-                <a16:creationId xmlns:a16="http://schemas.microsoft.com/office/drawing/2014/main" id="{EA6ED26D-BCEA-420D-8083-A179712DB11D}"/>
+                <a16:creationId xmlns:a16="http://schemas.microsoft.com/office/drawing/2014/main" id="{9CDC7696-3F48-4DAE-83E6-1E9AB9C1D598}"/>
               </a:ext>
             </a:extLst>
           </p:cNvPr>
@@ -7584,7 +7584,7 @@
           <p:cNvPr id="27" name="benchmark-label-2-text">
             <a:extLst xmlns:a="http://schemas.openxmlformats.org/drawingml/2006/main">
               <a:ext uri="{FF2B5EF4-FFF2-40B4-BE49-F238E27FC236}">
-                <a16:creationId xmlns:a16="http://schemas.microsoft.com/office/drawing/2014/main" id="{0E27BD7C-2C81-4D10-9BC6-C97C18F9929A}"/>
+                <a16:creationId xmlns:a16="http://schemas.microsoft.com/office/drawing/2014/main" id="{5FB896DB-711A-4693-B928-943030214E2F}"/>
               </a:ext>
             </a:extLst>
           </p:cNvPr>
@@ -7637,7 +7637,7 @@
           <p:cNvPr id="28" name="benchmark-merged-2-surface">
             <a:extLst xmlns:a="http://schemas.openxmlformats.org/drawingml/2006/main">
               <a:ext uri="{FF2B5EF4-FFF2-40B4-BE49-F238E27FC236}">
-                <a16:creationId xmlns:a16="http://schemas.microsoft.com/office/drawing/2014/main" id="{0A0ED828-0898-4E3E-B23B-F12A00964779}"/>
+                <a16:creationId xmlns:a16="http://schemas.microsoft.com/office/drawing/2014/main" id="{204ED4F0-EA82-4D60-B4A7-6FEDAFAD6946}"/>
               </a:ext>
             </a:extLst>
           </p:cNvPr>
@@ -7670,7 +7670,7 @@
           <p:cNvPr id="29" name="benchmark-merged-2-text">
             <a:extLst xmlns:a="http://schemas.openxmlformats.org/drawingml/2006/main">
               <a:ext uri="{FF2B5EF4-FFF2-40B4-BE49-F238E27FC236}">
-                <a16:creationId xmlns:a16="http://schemas.microsoft.com/office/drawing/2014/main" id="{539B4A99-1C6D-4F56-80F0-256CE9986A32}"/>
+                <a16:creationId xmlns:a16="http://schemas.microsoft.com/office/drawing/2014/main" id="{2D96AB6B-F6ED-4EF0-AA86-0632BDAF331E}"/>
               </a:ext>
             </a:extLst>
           </p:cNvPr>
@@ -7723,7 +7723,7 @@
           <p:cNvPr id="30" name="benchmark-label-3-surface">
             <a:extLst xmlns:a="http://schemas.openxmlformats.org/drawingml/2006/main">
               <a:ext uri="{FF2B5EF4-FFF2-40B4-BE49-F238E27FC236}">
-                <a16:creationId xmlns:a16="http://schemas.microsoft.com/office/drawing/2014/main" id="{1ABF3FBC-46F2-44EE-987E-16393A5B7D9C}"/>
+                <a16:creationId xmlns:a16="http://schemas.microsoft.com/office/drawing/2014/main" id="{C7180D4D-A806-4AF7-95B8-53D2275AF2C5}"/>
               </a:ext>
             </a:extLst>
           </p:cNvPr>
@@ -7756,7 +7756,7 @@
           <p:cNvPr id="31" name="benchmark-label-3-text">
             <a:extLst xmlns:a="http://schemas.openxmlformats.org/drawingml/2006/main">
               <a:ext uri="{FF2B5EF4-FFF2-40B4-BE49-F238E27FC236}">
-                <a16:creationId xmlns:a16="http://schemas.microsoft.com/office/drawing/2014/main" id="{88C2F739-E9CB-45C5-8274-5388AF9B25AE}"/>
+                <a16:creationId xmlns:a16="http://schemas.microsoft.com/office/drawing/2014/main" id="{17F83B02-FA8C-475F-9844-952D6FE976AD}"/>
               </a:ext>
             </a:extLst>
           </p:cNvPr>
@@ -7809,7 +7809,7 @@
           <p:cNvPr id="32" name="benchmark-left-3-surface">
             <a:extLst xmlns:a="http://schemas.openxmlformats.org/drawingml/2006/main">
               <a:ext uri="{FF2B5EF4-FFF2-40B4-BE49-F238E27FC236}">
-                <a16:creationId xmlns:a16="http://schemas.microsoft.com/office/drawing/2014/main" id="{5F483188-A48C-4125-BC12-0F5E27ED6D68}"/>
+                <a16:creationId xmlns:a16="http://schemas.microsoft.com/office/drawing/2014/main" id="{28413388-8022-4DB4-A192-F93A99EEAC98}"/>
               </a:ext>
             </a:extLst>
           </p:cNvPr>
@@ -7842,7 +7842,7 @@
           <p:cNvPr id="33" name="benchmark-left-3-text">
             <a:extLst xmlns:a="http://schemas.openxmlformats.org/drawingml/2006/main">
               <a:ext uri="{FF2B5EF4-FFF2-40B4-BE49-F238E27FC236}">
-                <a16:creationId xmlns:a16="http://schemas.microsoft.com/office/drawing/2014/main" id="{351B0458-487F-4F08-AB6B-23036B4D4808}"/>
+                <a16:creationId xmlns:a16="http://schemas.microsoft.com/office/drawing/2014/main" id="{E5015D27-6C08-430D-8DCA-81FA85D77279}"/>
               </a:ext>
             </a:extLst>
           </p:cNvPr>
@@ -7895,7 +7895,7 @@
           <p:cNvPr id="34" name="benchmark-right-3-surface">
             <a:extLst xmlns:a="http://schemas.openxmlformats.org/drawingml/2006/main">
               <a:ext uri="{FF2B5EF4-FFF2-40B4-BE49-F238E27FC236}">
-                <a16:creationId xmlns:a16="http://schemas.microsoft.com/office/drawing/2014/main" id="{7B1C647F-EEBF-4D4F-8263-1CC2B35D86CD}"/>
+                <a16:creationId xmlns:a16="http://schemas.microsoft.com/office/drawing/2014/main" id="{C01B922B-2753-43B7-935D-01E303EC9365}"/>
               </a:ext>
             </a:extLst>
           </p:cNvPr>
@@ -7928,7 +7928,7 @@
           <p:cNvPr id="35" name="benchmark-right-3-text">
             <a:extLst xmlns:a="http://schemas.openxmlformats.org/drawingml/2006/main">
               <a:ext uri="{FF2B5EF4-FFF2-40B4-BE49-F238E27FC236}">
-                <a16:creationId xmlns:a16="http://schemas.microsoft.com/office/drawing/2014/main" id="{2616EEB3-DBE3-403D-9A88-DCA34ABDD6E2}"/>
+                <a16:creationId xmlns:a16="http://schemas.microsoft.com/office/drawing/2014/main" id="{B1A91687-74AB-49ED-AAC8-560C99B18A3B}"/>
               </a:ext>
             </a:extLst>
           </p:cNvPr>
@@ -7981,7 +7981,7 @@
           <p:cNvPr id="36" name="benchmark-label-4-surface">
             <a:extLst xmlns:a="http://schemas.openxmlformats.org/drawingml/2006/main">
               <a:ext uri="{FF2B5EF4-FFF2-40B4-BE49-F238E27FC236}">
-                <a16:creationId xmlns:a16="http://schemas.microsoft.com/office/drawing/2014/main" id="{F83DB137-83B5-4865-871C-2BCEB4EF2D26}"/>
+                <a16:creationId xmlns:a16="http://schemas.microsoft.com/office/drawing/2014/main" id="{6BE7AC1B-B9A8-4264-88EC-0737C11AA31E}"/>
               </a:ext>
             </a:extLst>
           </p:cNvPr>
@@ -8014,7 +8014,7 @@
           <p:cNvPr id="37" name="benchmark-label-4-text">
             <a:extLst xmlns:a="http://schemas.openxmlformats.org/drawingml/2006/main">
               <a:ext uri="{FF2B5EF4-FFF2-40B4-BE49-F238E27FC236}">
-                <a16:creationId xmlns:a16="http://schemas.microsoft.com/office/drawing/2014/main" id="{2BEC8A1B-30B7-487C-A9C5-121FF89795C8}"/>
+                <a16:creationId xmlns:a16="http://schemas.microsoft.com/office/drawing/2014/main" id="{603B2769-86BB-4CE2-8411-3BAF30F4C414}"/>
               </a:ext>
             </a:extLst>
           </p:cNvPr>
@@ -8067,7 +8067,7 @@
           <p:cNvPr id="38" name="benchmark-left-4-surface">
             <a:extLst xmlns:a="http://schemas.openxmlformats.org/drawingml/2006/main">
               <a:ext uri="{FF2B5EF4-FFF2-40B4-BE49-F238E27FC236}">
-                <a16:creationId xmlns:a16="http://schemas.microsoft.com/office/drawing/2014/main" id="{AA3408C5-E6E0-4E60-993A-FA0A5811AFEC}"/>
+                <a16:creationId xmlns:a16="http://schemas.microsoft.com/office/drawing/2014/main" id="{A44A2711-345B-4E0A-A665-EE60359D0B6B}"/>
               </a:ext>
             </a:extLst>
           </p:cNvPr>
@@ -8100,7 +8100,7 @@
           <p:cNvPr id="39" name="benchmark-left-4-text">
             <a:extLst xmlns:a="http://schemas.openxmlformats.org/drawingml/2006/main">
               <a:ext uri="{FF2B5EF4-FFF2-40B4-BE49-F238E27FC236}">
-                <a16:creationId xmlns:a16="http://schemas.microsoft.com/office/drawing/2014/main" id="{411AE93F-4920-4271-AA9B-1322FE1A973B}"/>
+                <a16:creationId xmlns:a16="http://schemas.microsoft.com/office/drawing/2014/main" id="{DFBB67BA-B32F-4D0E-B1C9-12E7EFBB459A}"/>
               </a:ext>
             </a:extLst>
           </p:cNvPr>
@@ -8173,7 +8173,7 @@
           <p:cNvPr id="40" name="benchmark-right-4-surface">
             <a:extLst xmlns:a="http://schemas.openxmlformats.org/drawingml/2006/main">
               <a:ext uri="{FF2B5EF4-FFF2-40B4-BE49-F238E27FC236}">
-                <a16:creationId xmlns:a16="http://schemas.microsoft.com/office/drawing/2014/main" id="{4D36784F-19D9-4CD6-8241-43D4C40F16F4}"/>
+                <a16:creationId xmlns:a16="http://schemas.microsoft.com/office/drawing/2014/main" id="{597E2720-083B-435D-B57A-84537912DDF1}"/>
               </a:ext>
             </a:extLst>
           </p:cNvPr>
@@ -8206,7 +8206,7 @@
           <p:cNvPr id="41" name="benchmark-right-4-text">
             <a:extLst xmlns:a="http://schemas.openxmlformats.org/drawingml/2006/main">
               <a:ext uri="{FF2B5EF4-FFF2-40B4-BE49-F238E27FC236}">
-                <a16:creationId xmlns:a16="http://schemas.microsoft.com/office/drawing/2014/main" id="{38E96D64-E1A1-48C2-83BF-053D72C720AA}"/>
+                <a16:creationId xmlns:a16="http://schemas.microsoft.com/office/drawing/2014/main" id="{6B85CF67-1AEA-43F7-BC04-78B9F9F0EA68}"/>
               </a:ext>
             </a:extLst>
           </p:cNvPr>
@@ -8257,7 +8257,7 @@
     </p:spTree>
     <p:extLst>
       <p:ext uri="{BB962C8B-B14F-4D97-AF65-F5344CB8AC3E}">
-        <p14:creationId xmlns:p14="http://schemas.microsoft.com/office/powerpoint/2010/main" val="1880076968"/>
+        <p14:creationId xmlns:p14="http://schemas.microsoft.com/office/powerpoint/2010/main" val="1262674144"/>
       </p:ext>
     </p:extLst>
   </p:cSld>
@@ -8288,7 +8288,7 @@
           <p:cNvPr id="30" name="header-shadow-line">
             <a:extLst xmlns:a="http://schemas.openxmlformats.org/drawingml/2006/main">
               <a:ext uri="{FF2B5EF4-FFF2-40B4-BE49-F238E27FC236}">
-                <a16:creationId xmlns:a16="http://schemas.microsoft.com/office/drawing/2014/main" id="{B20A3CFF-52C8-400B-93B4-6BD1698DCC4F}"/>
+                <a16:creationId xmlns:a16="http://schemas.microsoft.com/office/drawing/2014/main" id="{581EBB15-B978-4347-8FC5-C8F9527FCBF0}"/>
               </a:ext>
             </a:extLst>
           </p:cNvPr>
@@ -8319,7 +8319,7 @@
           <p:cNvPr id="2" name="header-green-line">
             <a:extLst xmlns:a="http://schemas.openxmlformats.org/drawingml/2006/main">
               <a:ext uri="{FF2B5EF4-FFF2-40B4-BE49-F238E27FC236}">
-                <a16:creationId xmlns:a16="http://schemas.microsoft.com/office/drawing/2014/main" id="{F05B3171-2F49-4E53-BE58-F9E91F8ADEC8}"/>
+                <a16:creationId xmlns:a16="http://schemas.microsoft.com/office/drawing/2014/main" id="{2E547FDE-3E30-4995-9E67-CD2E2AF0BDAC}"/>
               </a:ext>
             </a:extLst>
           </p:cNvPr>
@@ -8350,7 +8350,7 @@
           <p:cNvPr id="3" name="page-number-block">
             <a:extLst xmlns:a="http://schemas.openxmlformats.org/drawingml/2006/main">
               <a:ext uri="{FF2B5EF4-FFF2-40B4-BE49-F238E27FC236}">
-                <a16:creationId xmlns:a16="http://schemas.microsoft.com/office/drawing/2014/main" id="{C4ED8F17-867D-48B5-AA59-9ADC4EE9B350}"/>
+                <a16:creationId xmlns:a16="http://schemas.microsoft.com/office/drawing/2014/main" id="{2444C457-9E0E-4779-914E-1B5C96C6A0AC}"/>
               </a:ext>
             </a:extLst>
           </p:cNvPr>
@@ -8381,7 +8381,7 @@
           <p:cNvPr id="4" name="page-number">
             <a:extLst xmlns:a="http://schemas.openxmlformats.org/drawingml/2006/main">
               <a:ext uri="{FF2B5EF4-FFF2-40B4-BE49-F238E27FC236}">
-                <a16:creationId xmlns:a16="http://schemas.microsoft.com/office/drawing/2014/main" id="{48D1ADAF-9952-4CDE-AD60-C9F9DA94C31D}"/>
+                <a16:creationId xmlns:a16="http://schemas.microsoft.com/office/drawing/2014/main" id="{C91E1667-21F3-4042-903A-A6CA42D392EB}"/>
               </a:ext>
             </a:extLst>
           </p:cNvPr>
@@ -8434,7 +8434,7 @@
           <p:cNvPr id="5" name="page-title">
             <a:extLst xmlns:a="http://schemas.openxmlformats.org/drawingml/2006/main">
               <a:ext uri="{FF2B5EF4-FFF2-40B4-BE49-F238E27FC236}">
-                <a16:creationId xmlns:a16="http://schemas.microsoft.com/office/drawing/2014/main" id="{73DA4B04-9304-407F-AEFE-D0335CBF1BB3}"/>
+                <a16:creationId xmlns:a16="http://schemas.microsoft.com/office/drawing/2014/main" id="{930594F5-3DBE-4BF9-9F30-3C11B3128128}"/>
               </a:ext>
             </a:extLst>
           </p:cNvPr>
@@ -8487,7 +8487,7 @@
           <p:cNvPr id="6" name="brand-wordmark">
             <a:extLst xmlns:a="http://schemas.openxmlformats.org/drawingml/2006/main">
               <a:ext uri="{FF2B5EF4-FFF2-40B4-BE49-F238E27FC236}">
-                <a16:creationId xmlns:a16="http://schemas.microsoft.com/office/drawing/2014/main" id="{2257EE60-E9F8-47FF-8246-BB74F44E31B6}"/>
+                <a16:creationId xmlns:a16="http://schemas.microsoft.com/office/drawing/2014/main" id="{81821918-6E69-4CA4-ABB1-88E6F8AC38A9}"/>
               </a:ext>
             </a:extLst>
           </p:cNvPr>
@@ -8540,7 +8540,7 @@
           <p:cNvPr id="7" name="internal-notice">
             <a:extLst xmlns:a="http://schemas.openxmlformats.org/drawingml/2006/main">
               <a:ext uri="{FF2B5EF4-FFF2-40B4-BE49-F238E27FC236}">
-                <a16:creationId xmlns:a16="http://schemas.microsoft.com/office/drawing/2014/main" id="{D0B5FC41-8B73-4350-B677-142A5D52A671}"/>
+                <a16:creationId xmlns:a16="http://schemas.microsoft.com/office/drawing/2014/main" id="{23A00648-19C6-4CBE-B75F-925DE58538CF}"/>
               </a:ext>
             </a:extLst>
           </p:cNvPr>
@@ -8593,7 +8593,7 @@
           <p:cNvPr id="8" name="precautions-label">
             <a:extLst xmlns:a="http://schemas.openxmlformats.org/drawingml/2006/main">
               <a:ext uri="{FF2B5EF4-FFF2-40B4-BE49-F238E27FC236}">
-                <a16:creationId xmlns:a16="http://schemas.microsoft.com/office/drawing/2014/main" id="{7D828FA0-8FC9-4ACB-883C-0CE8C4F45E45}"/>
+                <a16:creationId xmlns:a16="http://schemas.microsoft.com/office/drawing/2014/main" id="{D88E44E8-4A63-48A4-9230-C40104327E19}"/>
               </a:ext>
             </a:extLst>
           </p:cNvPr>
@@ -8648,7 +8648,7 @@
           <p:cNvPr id="9" name="precaution-item-0">
             <a:extLst xmlns:a="http://schemas.openxmlformats.org/drawingml/2006/main">
               <a:ext uri="{FF2B5EF4-FFF2-40B4-BE49-F238E27FC236}">
-                <a16:creationId xmlns:a16="http://schemas.microsoft.com/office/drawing/2014/main" id="{A18128A3-8432-4844-88C0-F01A406CC5A3}"/>
+                <a16:creationId xmlns:a16="http://schemas.microsoft.com/office/drawing/2014/main" id="{97709F9E-AFA5-4E38-90BD-30AFA221A133}"/>
               </a:ext>
             </a:extLst>
           </p:cNvPr>
@@ -8701,7 +8701,7 @@
           <p:cNvPr id="10" name="precaution-item-1">
             <a:extLst xmlns:a="http://schemas.openxmlformats.org/drawingml/2006/main">
               <a:ext uri="{FF2B5EF4-FFF2-40B4-BE49-F238E27FC236}">
-                <a16:creationId xmlns:a16="http://schemas.microsoft.com/office/drawing/2014/main" id="{2D747461-DD1D-4934-BFF8-F46B0EE65943}"/>
+                <a16:creationId xmlns:a16="http://schemas.microsoft.com/office/drawing/2014/main" id="{D0FFD48B-58BD-4B6D-9AD5-1AA0F04A3124}"/>
               </a:ext>
             </a:extLst>
           </p:cNvPr>
@@ -8754,7 +8754,7 @@
           <p:cNvPr id="11" name="precaution-item-2">
             <a:extLst xmlns:a="http://schemas.openxmlformats.org/drawingml/2006/main">
               <a:ext uri="{FF2B5EF4-FFF2-40B4-BE49-F238E27FC236}">
-                <a16:creationId xmlns:a16="http://schemas.microsoft.com/office/drawing/2014/main" id="{C9270BC9-13CC-4A0E-985B-10E8CEB1F714}"/>
+                <a16:creationId xmlns:a16="http://schemas.microsoft.com/office/drawing/2014/main" id="{B4887807-2A7D-47E9-957E-A72C67B0819E}"/>
               </a:ext>
             </a:extLst>
           </p:cNvPr>
@@ -8807,7 +8807,7 @@
           <p:cNvPr id="12" name="precaution-item-3">
             <a:extLst xmlns:a="http://schemas.openxmlformats.org/drawingml/2006/main">
               <a:ext uri="{FF2B5EF4-FFF2-40B4-BE49-F238E27FC236}">
-                <a16:creationId xmlns:a16="http://schemas.microsoft.com/office/drawing/2014/main" id="{0B0D134F-A5D2-42E0-8271-67B71CBCDAAC}"/>
+                <a16:creationId xmlns:a16="http://schemas.microsoft.com/office/drawing/2014/main" id="{AC536E8D-10DC-4CFA-9081-D0334DBBD08A}"/>
               </a:ext>
             </a:extLst>
           </p:cNvPr>
@@ -8860,7 +8860,7 @@
           <p:cNvPr id="13" name="precaution-item-4">
             <a:extLst xmlns:a="http://schemas.openxmlformats.org/drawingml/2006/main">
               <a:ext uri="{FF2B5EF4-FFF2-40B4-BE49-F238E27FC236}">
-                <a16:creationId xmlns:a16="http://schemas.microsoft.com/office/drawing/2014/main" id="{DF202C8F-5924-42C5-901A-32525C8C1A7A}"/>
+                <a16:creationId xmlns:a16="http://schemas.microsoft.com/office/drawing/2014/main" id="{F28917F3-A0E8-4A71-B43C-CA30ABAFCFDA}"/>
               </a:ext>
             </a:extLst>
           </p:cNvPr>
@@ -8913,7 +8913,7 @@
           <p:cNvPr id="14" name="precaution-card-0">
             <a:extLst xmlns:a="http://schemas.openxmlformats.org/drawingml/2006/main">
               <a:ext uri="{FF2B5EF4-FFF2-40B4-BE49-F238E27FC236}">
-                <a16:creationId xmlns:a16="http://schemas.microsoft.com/office/drawing/2014/main" id="{E4384D9F-DEF9-4C70-8B83-8C5D922AB0D0}"/>
+                <a16:creationId xmlns:a16="http://schemas.microsoft.com/office/drawing/2014/main" id="{2E33392B-B4D4-4A8B-9279-77D35C40EEFE}"/>
               </a:ext>
             </a:extLst>
           </p:cNvPr>
@@ -8946,7 +8946,7 @@
           <p:cNvPr id="15" name="precaution-card-title-0">
             <a:extLst xmlns:a="http://schemas.openxmlformats.org/drawingml/2006/main">
               <a:ext uri="{FF2B5EF4-FFF2-40B4-BE49-F238E27FC236}">
-                <a16:creationId xmlns:a16="http://schemas.microsoft.com/office/drawing/2014/main" id="{67C70946-2B13-4CB2-80A1-FA8843E01421}"/>
+                <a16:creationId xmlns:a16="http://schemas.microsoft.com/office/drawing/2014/main" id="{90DB5F4D-D0F3-4A2E-9A1A-91E3B9E063B6}"/>
               </a:ext>
             </a:extLst>
           </p:cNvPr>
@@ -8999,7 +8999,7 @@
           <p:cNvPr id="16" name="precaution-asset-0-surface">
             <a:extLst xmlns:a="http://schemas.openxmlformats.org/drawingml/2006/main">
               <a:ext uri="{FF2B5EF4-FFF2-40B4-BE49-F238E27FC236}">
-                <a16:creationId xmlns:a16="http://schemas.microsoft.com/office/drawing/2014/main" id="{155FAB6A-8EEA-4514-8E88-A1D646A36331}"/>
+                <a16:creationId xmlns:a16="http://schemas.microsoft.com/office/drawing/2014/main" id="{03CF7F70-3799-4871-96D1-17223B8B2622}"/>
               </a:ext>
             </a:extLst>
           </p:cNvPr>
@@ -9032,7 +9032,7 @@
           <p:cNvPr id="17" name="precaution-asset-0-label">
             <a:extLst xmlns:a="http://schemas.openxmlformats.org/drawingml/2006/main">
               <a:ext uri="{FF2B5EF4-FFF2-40B4-BE49-F238E27FC236}">
-                <a16:creationId xmlns:a16="http://schemas.microsoft.com/office/drawing/2014/main" id="{256B0BF8-FA18-4257-B4A0-922DBFA9D689}"/>
+                <a16:creationId xmlns:a16="http://schemas.microsoft.com/office/drawing/2014/main" id="{290B864A-EF42-4F96-A046-BF1AAB47976A}"/>
               </a:ext>
             </a:extLst>
           </p:cNvPr>
@@ -9105,7 +9105,7 @@
           <p:cNvPr id="18" name="precaution-card-1">
             <a:extLst xmlns:a="http://schemas.openxmlformats.org/drawingml/2006/main">
               <a:ext uri="{FF2B5EF4-FFF2-40B4-BE49-F238E27FC236}">
-                <a16:creationId xmlns:a16="http://schemas.microsoft.com/office/drawing/2014/main" id="{CD9902A3-C135-4E8F-AD29-082C4BB81474}"/>
+                <a16:creationId xmlns:a16="http://schemas.microsoft.com/office/drawing/2014/main" id="{8D1E3F5E-D4DA-4F74-B752-2BF475602E72}"/>
               </a:ext>
             </a:extLst>
           </p:cNvPr>
@@ -9138,7 +9138,7 @@
           <p:cNvPr id="19" name="precaution-card-title-1">
             <a:extLst xmlns:a="http://schemas.openxmlformats.org/drawingml/2006/main">
               <a:ext uri="{FF2B5EF4-FFF2-40B4-BE49-F238E27FC236}">
-                <a16:creationId xmlns:a16="http://schemas.microsoft.com/office/drawing/2014/main" id="{989DDFED-549D-4DEE-B627-CD71E557EF8C}"/>
+                <a16:creationId xmlns:a16="http://schemas.microsoft.com/office/drawing/2014/main" id="{02458787-EBAD-404C-B16F-1B5C5163CDC0}"/>
               </a:ext>
             </a:extLst>
           </p:cNvPr>
@@ -9191,7 +9191,7 @@
           <p:cNvPr id="20" name="precaution-asset-1-surface">
             <a:extLst xmlns:a="http://schemas.openxmlformats.org/drawingml/2006/main">
               <a:ext uri="{FF2B5EF4-FFF2-40B4-BE49-F238E27FC236}">
-                <a16:creationId xmlns:a16="http://schemas.microsoft.com/office/drawing/2014/main" id="{B43C3D74-D255-4C1C-BE87-19489AD310F0}"/>
+                <a16:creationId xmlns:a16="http://schemas.microsoft.com/office/drawing/2014/main" id="{667C2754-15CA-43FD-A11A-F7E678179A29}"/>
               </a:ext>
             </a:extLst>
           </p:cNvPr>
@@ -9224,7 +9224,7 @@
           <p:cNvPr id="21" name="precaution-asset-1-label">
             <a:extLst xmlns:a="http://schemas.openxmlformats.org/drawingml/2006/main">
               <a:ext uri="{FF2B5EF4-FFF2-40B4-BE49-F238E27FC236}">
-                <a16:creationId xmlns:a16="http://schemas.microsoft.com/office/drawing/2014/main" id="{64098045-B079-484C-8B0F-5D838E1F992B}"/>
+                <a16:creationId xmlns:a16="http://schemas.microsoft.com/office/drawing/2014/main" id="{C58A801D-3E67-4216-BB5E-0F969310D97D}"/>
               </a:ext>
             </a:extLst>
           </p:cNvPr>
@@ -9297,7 +9297,7 @@
           <p:cNvPr id="22" name="precaution-card-2">
             <a:extLst xmlns:a="http://schemas.openxmlformats.org/drawingml/2006/main">
               <a:ext uri="{FF2B5EF4-FFF2-40B4-BE49-F238E27FC236}">
-                <a16:creationId xmlns:a16="http://schemas.microsoft.com/office/drawing/2014/main" id="{F3AAC95B-49C3-4292-A24C-5309907B711E}"/>
+                <a16:creationId xmlns:a16="http://schemas.microsoft.com/office/drawing/2014/main" id="{F1CC7EB1-C889-493C-A82C-E667B7594494}"/>
               </a:ext>
             </a:extLst>
           </p:cNvPr>
@@ -9330,7 +9330,7 @@
           <p:cNvPr id="23" name="precaution-card-title-2">
             <a:extLst xmlns:a="http://schemas.openxmlformats.org/drawingml/2006/main">
               <a:ext uri="{FF2B5EF4-FFF2-40B4-BE49-F238E27FC236}">
-                <a16:creationId xmlns:a16="http://schemas.microsoft.com/office/drawing/2014/main" id="{E0763AD8-9BFD-49F3-BD00-32587C4F2D84}"/>
+                <a16:creationId xmlns:a16="http://schemas.microsoft.com/office/drawing/2014/main" id="{2EE1FCAE-B2E0-4A68-A4A1-6D5437A44910}"/>
               </a:ext>
             </a:extLst>
           </p:cNvPr>
@@ -9383,7 +9383,7 @@
           <p:cNvPr id="24" name="precaution-asset-2-surface">
             <a:extLst xmlns:a="http://schemas.openxmlformats.org/drawingml/2006/main">
               <a:ext uri="{FF2B5EF4-FFF2-40B4-BE49-F238E27FC236}">
-                <a16:creationId xmlns:a16="http://schemas.microsoft.com/office/drawing/2014/main" id="{14BAB446-25B9-4935-AA19-D78725695817}"/>
+                <a16:creationId xmlns:a16="http://schemas.microsoft.com/office/drawing/2014/main" id="{6EF4C6F0-BD0C-49F9-82F9-5714348D9142}"/>
               </a:ext>
             </a:extLst>
           </p:cNvPr>
@@ -9416,7 +9416,7 @@
           <p:cNvPr id="25" name="precaution-asset-2-label">
             <a:extLst xmlns:a="http://schemas.openxmlformats.org/drawingml/2006/main">
               <a:ext uri="{FF2B5EF4-FFF2-40B4-BE49-F238E27FC236}">
-                <a16:creationId xmlns:a16="http://schemas.microsoft.com/office/drawing/2014/main" id="{F02BCFAF-36C4-449F-8488-5575604F068A}"/>
+                <a16:creationId xmlns:a16="http://schemas.microsoft.com/office/drawing/2014/main" id="{368C4013-113E-4F6A-B1D0-FBBF2D763DA7}"/>
               </a:ext>
             </a:extLst>
           </p:cNvPr>
@@ -9489,7 +9489,7 @@
           <p:cNvPr id="26" name="precaution-card-3">
             <a:extLst xmlns:a="http://schemas.openxmlformats.org/drawingml/2006/main">
               <a:ext uri="{FF2B5EF4-FFF2-40B4-BE49-F238E27FC236}">
-                <a16:creationId xmlns:a16="http://schemas.microsoft.com/office/drawing/2014/main" id="{9A2A499A-8B5E-40C3-9EA7-AC8ABEEFE6AE}"/>
+                <a16:creationId xmlns:a16="http://schemas.microsoft.com/office/drawing/2014/main" id="{22738DC6-3DD0-42BF-8114-F4C8FA1BD957}"/>
               </a:ext>
             </a:extLst>
           </p:cNvPr>
@@ -9522,7 +9522,7 @@
           <p:cNvPr id="27" name="precaution-card-title-3">
             <a:extLst xmlns:a="http://schemas.openxmlformats.org/drawingml/2006/main">
               <a:ext uri="{FF2B5EF4-FFF2-40B4-BE49-F238E27FC236}">
-                <a16:creationId xmlns:a16="http://schemas.microsoft.com/office/drawing/2014/main" id="{AAAE6D1B-ADAF-4E31-8C73-8B23CE0A7B53}"/>
+                <a16:creationId xmlns:a16="http://schemas.microsoft.com/office/drawing/2014/main" id="{7127010C-C4DC-4372-8415-BB9156F0F1B3}"/>
               </a:ext>
             </a:extLst>
           </p:cNvPr>
@@ -9575,7 +9575,7 @@
           <p:cNvPr id="28" name="precaution-asset-3-surface">
             <a:extLst xmlns:a="http://schemas.openxmlformats.org/drawingml/2006/main">
               <a:ext uri="{FF2B5EF4-FFF2-40B4-BE49-F238E27FC236}">
-                <a16:creationId xmlns:a16="http://schemas.microsoft.com/office/drawing/2014/main" id="{59DC7194-86AE-46A2-9D42-F54681896CA4}"/>
+                <a16:creationId xmlns:a16="http://schemas.microsoft.com/office/drawing/2014/main" id="{A39FC716-C9A3-497A-92A1-584D552DDBF1}"/>
               </a:ext>
             </a:extLst>
           </p:cNvPr>
@@ -9608,7 +9608,7 @@
           <p:cNvPr id="29" name="precaution-asset-3-label">
             <a:extLst xmlns:a="http://schemas.openxmlformats.org/drawingml/2006/main">
               <a:ext uri="{FF2B5EF4-FFF2-40B4-BE49-F238E27FC236}">
-                <a16:creationId xmlns:a16="http://schemas.microsoft.com/office/drawing/2014/main" id="{22BF7C25-6B1C-42CA-B87C-27BF53605D77}"/>
+                <a16:creationId xmlns:a16="http://schemas.microsoft.com/office/drawing/2014/main" id="{AA0C6C86-4DCC-4CAF-B338-8D099C4F9E0C}"/>
               </a:ext>
             </a:extLst>
           </p:cNvPr>
@@ -9679,7 +9679,7 @@
     </p:spTree>
     <p:extLst>
       <p:ext uri="{BB962C8B-B14F-4D97-AF65-F5344CB8AC3E}">
-        <p14:creationId xmlns:p14="http://schemas.microsoft.com/office/powerpoint/2010/main" val="1182744639"/>
+        <p14:creationId xmlns:p14="http://schemas.microsoft.com/office/powerpoint/2010/main" val="540265927"/>
       </p:ext>
     </p:extLst>
   </p:cSld>

</xml_diff>